<commit_message>
fix: Update presentation slides for clarity and improved content structure
</commit_message>
<xml_diff>
--- a/presentation/Real-time Communication on the Web.pptx
+++ b/presentation/Real-time Communication on the Web.pptx
@@ -134,6 +134,226 @@
 </p:presentation>
 </file>
 
+<file path=ppt/revisionInfo.xml><?xml version="1.0" encoding="utf-8"?>
+<p1510:revInfo xmlns:a="http://schemas.openxmlformats.org/drawingml/2006/main" xmlns:r="http://schemas.openxmlformats.org/officeDocument/2006/relationships" xmlns:p1510="http://schemas.microsoft.com/office/powerpoint/2015/10/main">
+  <p1510:revLst>
+    <p1510:client id="{77F4BD5E-CA64-1597-1257-D40010619267}" v="149" dt="2026-10-16T03:18:27.314"/>
+    <p1510:client id="{ED7BB4BA-4E28-7097-5881-1B249348EB8A}" v="31" dt="2026-10-16T02:27:47.836"/>
+  </p1510:revLst>
+</p1510:revInfo>
+</file>
+
+<file path=ppt/changesInfos/changesInfo1.xml><?xml version="1.0" encoding="utf-8"?>
+<pc:chgInfo xmlns:a="http://schemas.openxmlformats.org/drawingml/2006/main" xmlns:r="http://schemas.openxmlformats.org/officeDocument/2006/relationships" xmlns:ac="http://schemas.microsoft.com/office/drawing/2013/main/command" xmlns:pc="http://schemas.microsoft.com/office/powerpoint/2013/main/command">
+  <pc:docChgLst>
+    <pc:chgData name="Tavian Nguyen" userId="S::tavian.n@itcgroup.io::aa81296b-9269-404a-b3a4-a824e4f2ee15" providerId="AD" clId="Web-{ED7BB4BA-4E28-7097-5881-1B249348EB8A}"/>
+    <pc:docChg chg="modSld">
+      <pc:chgData name="Tavian Nguyen" userId="S::tavian.n@itcgroup.io::aa81296b-9269-404a-b3a4-a824e4f2ee15" providerId="AD" clId="Web-{ED7BB4BA-4E28-7097-5881-1B249348EB8A}" dt="2026-10-16T02:27:47.836" v="29" actId="1076"/>
+      <pc:docMkLst>
+        <pc:docMk/>
+      </pc:docMkLst>
+      <pc:sldChg chg="delSp modSp">
+        <pc:chgData name="Tavian Nguyen" userId="S::tavian.n@itcgroup.io::aa81296b-9269-404a-b3a4-a824e4f2ee15" providerId="AD" clId="Web-{ED7BB4BA-4E28-7097-5881-1B249348EB8A}" dt="2026-10-16T02:27:47.836" v="29" actId="1076"/>
+        <pc:sldMkLst>
+          <pc:docMk/>
+          <pc:sldMk cId="0" sldId="266"/>
+        </pc:sldMkLst>
+        <pc:spChg chg="mod">
+          <ac:chgData name="Tavian Nguyen" userId="S::tavian.n@itcgroup.io::aa81296b-9269-404a-b3a4-a824e4f2ee15" providerId="AD" clId="Web-{ED7BB4BA-4E28-7097-5881-1B249348EB8A}" dt="2026-10-16T02:27:47.398" v="18" actId="1076"/>
+          <ac:spMkLst>
+            <pc:docMk/>
+            <pc:sldMk cId="0" sldId="266"/>
+            <ac:spMk id="34" creationId="{00000000-0000-0000-0000-000000000000}"/>
+          </ac:spMkLst>
+        </pc:spChg>
+        <pc:spChg chg="mod">
+          <ac:chgData name="Tavian Nguyen" userId="S::tavian.n@itcgroup.io::aa81296b-9269-404a-b3a4-a824e4f2ee15" providerId="AD" clId="Web-{ED7BB4BA-4E28-7097-5881-1B249348EB8A}" dt="2026-10-16T02:27:47.429" v="19" actId="1076"/>
+          <ac:spMkLst>
+            <pc:docMk/>
+            <pc:sldMk cId="0" sldId="266"/>
+            <ac:spMk id="35" creationId="{00000000-0000-0000-0000-000000000000}"/>
+          </ac:spMkLst>
+        </pc:spChg>
+        <pc:spChg chg="mod">
+          <ac:chgData name="Tavian Nguyen" userId="S::tavian.n@itcgroup.io::aa81296b-9269-404a-b3a4-a824e4f2ee15" providerId="AD" clId="Web-{ED7BB4BA-4E28-7097-5881-1B249348EB8A}" dt="2026-10-16T02:27:47.476" v="20" actId="1076"/>
+          <ac:spMkLst>
+            <pc:docMk/>
+            <pc:sldMk cId="0" sldId="266"/>
+            <ac:spMk id="36" creationId="{00000000-0000-0000-0000-000000000000}"/>
+          </ac:spMkLst>
+        </pc:spChg>
+        <pc:spChg chg="del mod">
+          <ac:chgData name="Tavian Nguyen" userId="S::tavian.n@itcgroup.io::aa81296b-9269-404a-b3a4-a824e4f2ee15" providerId="AD" clId="Web-{ED7BB4BA-4E28-7097-5881-1B249348EB8A}" dt="2026-10-16T02:27:02.351" v="2"/>
+          <ac:spMkLst>
+            <pc:docMk/>
+            <pc:sldMk cId="0" sldId="266"/>
+            <ac:spMk id="37" creationId="{00000000-0000-0000-0000-000000000000}"/>
+          </ac:spMkLst>
+        </pc:spChg>
+        <pc:spChg chg="mod">
+          <ac:chgData name="Tavian Nguyen" userId="S::tavian.n@itcgroup.io::aa81296b-9269-404a-b3a4-a824e4f2ee15" providerId="AD" clId="Web-{ED7BB4BA-4E28-7097-5881-1B249348EB8A}" dt="2026-10-16T02:27:47.508" v="21" actId="1076"/>
+          <ac:spMkLst>
+            <pc:docMk/>
+            <pc:sldMk cId="0" sldId="266"/>
+            <ac:spMk id="39" creationId="{00000000-0000-0000-0000-000000000000}"/>
+          </ac:spMkLst>
+        </pc:spChg>
+        <pc:spChg chg="mod">
+          <ac:chgData name="Tavian Nguyen" userId="S::tavian.n@itcgroup.io::aa81296b-9269-404a-b3a4-a824e4f2ee15" providerId="AD" clId="Web-{ED7BB4BA-4E28-7097-5881-1B249348EB8A}" dt="2026-10-16T02:27:47.554" v="22" actId="1076"/>
+          <ac:spMkLst>
+            <pc:docMk/>
+            <pc:sldMk cId="0" sldId="266"/>
+            <ac:spMk id="40" creationId="{00000000-0000-0000-0000-000000000000}"/>
+          </ac:spMkLst>
+        </pc:spChg>
+        <pc:spChg chg="mod">
+          <ac:chgData name="Tavian Nguyen" userId="S::tavian.n@itcgroup.io::aa81296b-9269-404a-b3a4-a824e4f2ee15" providerId="AD" clId="Web-{ED7BB4BA-4E28-7097-5881-1B249348EB8A}" dt="2026-10-16T02:27:47.586" v="23" actId="1076"/>
+          <ac:spMkLst>
+            <pc:docMk/>
+            <pc:sldMk cId="0" sldId="266"/>
+            <ac:spMk id="41" creationId="{00000000-0000-0000-0000-000000000000}"/>
+          </ac:spMkLst>
+        </pc:spChg>
+        <pc:spChg chg="del">
+          <ac:chgData name="Tavian Nguyen" userId="S::tavian.n@itcgroup.io::aa81296b-9269-404a-b3a4-a824e4f2ee15" providerId="AD" clId="Web-{ED7BB4BA-4E28-7097-5881-1B249348EB8A}" dt="2026-10-16T02:27:09.788" v="3"/>
+          <ac:spMkLst>
+            <pc:docMk/>
+            <pc:sldMk cId="0" sldId="266"/>
+            <ac:spMk id="42" creationId="{00000000-0000-0000-0000-000000000000}"/>
+          </ac:spMkLst>
+        </pc:spChg>
+        <pc:spChg chg="mod">
+          <ac:chgData name="Tavian Nguyen" userId="S::tavian.n@itcgroup.io::aa81296b-9269-404a-b3a4-a824e4f2ee15" providerId="AD" clId="Web-{ED7BB4BA-4E28-7097-5881-1B249348EB8A}" dt="2026-10-16T02:27:47.633" v="24" actId="1076"/>
+          <ac:spMkLst>
+            <pc:docMk/>
+            <pc:sldMk cId="0" sldId="266"/>
+            <ac:spMk id="44" creationId="{00000000-0000-0000-0000-000000000000}"/>
+          </ac:spMkLst>
+        </pc:spChg>
+        <pc:spChg chg="mod">
+          <ac:chgData name="Tavian Nguyen" userId="S::tavian.n@itcgroup.io::aa81296b-9269-404a-b3a4-a824e4f2ee15" providerId="AD" clId="Web-{ED7BB4BA-4E28-7097-5881-1B249348EB8A}" dt="2026-10-16T02:27:47.664" v="25" actId="1076"/>
+          <ac:spMkLst>
+            <pc:docMk/>
+            <pc:sldMk cId="0" sldId="266"/>
+            <ac:spMk id="45" creationId="{00000000-0000-0000-0000-000000000000}"/>
+          </ac:spMkLst>
+        </pc:spChg>
+        <pc:spChg chg="mod">
+          <ac:chgData name="Tavian Nguyen" userId="S::tavian.n@itcgroup.io::aa81296b-9269-404a-b3a4-a824e4f2ee15" providerId="AD" clId="Web-{ED7BB4BA-4E28-7097-5881-1B249348EB8A}" dt="2026-10-16T02:27:47.711" v="26" actId="1076"/>
+          <ac:spMkLst>
+            <pc:docMk/>
+            <pc:sldMk cId="0" sldId="266"/>
+            <ac:spMk id="46" creationId="{00000000-0000-0000-0000-000000000000}"/>
+          </ac:spMkLst>
+        </pc:spChg>
+        <pc:spChg chg="del">
+          <ac:chgData name="Tavian Nguyen" userId="S::tavian.n@itcgroup.io::aa81296b-9269-404a-b3a4-a824e4f2ee15" providerId="AD" clId="Web-{ED7BB4BA-4E28-7097-5881-1B249348EB8A}" dt="2026-10-16T02:27:16.117" v="4"/>
+          <ac:spMkLst>
+            <pc:docMk/>
+            <pc:sldMk cId="0" sldId="266"/>
+            <ac:spMk id="47" creationId="{00000000-0000-0000-0000-000000000000}"/>
+          </ac:spMkLst>
+        </pc:spChg>
+        <pc:spChg chg="mod">
+          <ac:chgData name="Tavian Nguyen" userId="S::tavian.n@itcgroup.io::aa81296b-9269-404a-b3a4-a824e4f2ee15" providerId="AD" clId="Web-{ED7BB4BA-4E28-7097-5881-1B249348EB8A}" dt="2026-10-16T02:27:47.758" v="27" actId="1076"/>
+          <ac:spMkLst>
+            <pc:docMk/>
+            <pc:sldMk cId="0" sldId="266"/>
+            <ac:spMk id="49" creationId="{00000000-0000-0000-0000-000000000000}"/>
+          </ac:spMkLst>
+        </pc:spChg>
+        <pc:spChg chg="mod">
+          <ac:chgData name="Tavian Nguyen" userId="S::tavian.n@itcgroup.io::aa81296b-9269-404a-b3a4-a824e4f2ee15" providerId="AD" clId="Web-{ED7BB4BA-4E28-7097-5881-1B249348EB8A}" dt="2026-10-16T02:27:47.789" v="28" actId="1076"/>
+          <ac:spMkLst>
+            <pc:docMk/>
+            <pc:sldMk cId="0" sldId="266"/>
+            <ac:spMk id="50" creationId="{00000000-0000-0000-0000-000000000000}"/>
+          </ac:spMkLst>
+        </pc:spChg>
+        <pc:spChg chg="mod">
+          <ac:chgData name="Tavian Nguyen" userId="S::tavian.n@itcgroup.io::aa81296b-9269-404a-b3a4-a824e4f2ee15" providerId="AD" clId="Web-{ED7BB4BA-4E28-7097-5881-1B249348EB8A}" dt="2026-10-16T02:27:47.836" v="29" actId="1076"/>
+          <ac:spMkLst>
+            <pc:docMk/>
+            <pc:sldMk cId="0" sldId="266"/>
+            <ac:spMk id="51" creationId="{00000000-0000-0000-0000-000000000000}"/>
+          </ac:spMkLst>
+        </pc:spChg>
+        <pc:spChg chg="del">
+          <ac:chgData name="Tavian Nguyen" userId="S::tavian.n@itcgroup.io::aa81296b-9269-404a-b3a4-a824e4f2ee15" providerId="AD" clId="Web-{ED7BB4BA-4E28-7097-5881-1B249348EB8A}" dt="2026-10-16T02:27:19.101" v="5"/>
+          <ac:spMkLst>
+            <pc:docMk/>
+            <pc:sldMk cId="0" sldId="266"/>
+            <ac:spMk id="52" creationId="{00000000-0000-0000-0000-000000000000}"/>
+          </ac:spMkLst>
+        </pc:spChg>
+      </pc:sldChg>
+    </pc:docChg>
+  </pc:docChgLst>
+  <pc:docChgLst>
+    <pc:chgData name="Tavian Nguyen" userId="S::tavian.n@itcgroup.io::aa81296b-9269-404a-b3a4-a824e4f2ee15" providerId="AD" clId="Web-{77F4BD5E-CA64-1597-1257-D40010619267}"/>
+    <pc:docChg chg="modSld">
+      <pc:chgData name="Tavian Nguyen" userId="S::tavian.n@itcgroup.io::aa81296b-9269-404a-b3a4-a824e4f2ee15" providerId="AD" clId="Web-{77F4BD5E-CA64-1597-1257-D40010619267}" dt="2026-10-16T03:18:26.377" v="85" actId="20577"/>
+      <pc:docMkLst>
+        <pc:docMk/>
+      </pc:docMkLst>
+      <pc:sldChg chg="modSp">
+        <pc:chgData name="Tavian Nguyen" userId="S::tavian.n@itcgroup.io::aa81296b-9269-404a-b3a4-a824e4f2ee15" providerId="AD" clId="Web-{77F4BD5E-CA64-1597-1257-D40010619267}" dt="2026-10-16T03:18:26.377" v="85" actId="20577"/>
+        <pc:sldMkLst>
+          <pc:docMk/>
+          <pc:sldMk cId="0" sldId="257"/>
+        </pc:sldMkLst>
+        <pc:spChg chg="mod">
+          <ac:chgData name="Tavian Nguyen" userId="S::tavian.n@itcgroup.io::aa81296b-9269-404a-b3a4-a824e4f2ee15" providerId="AD" clId="Web-{77F4BD5E-CA64-1597-1257-D40010619267}" dt="2026-10-16T03:18:26.377" v="85" actId="20577"/>
+          <ac:spMkLst>
+            <pc:docMk/>
+            <pc:sldMk cId="0" sldId="257"/>
+            <ac:spMk id="18" creationId="{00000000-0000-0000-0000-000000000000}"/>
+          </ac:spMkLst>
+        </pc:spChg>
+      </pc:sldChg>
+      <pc:sldChg chg="modSp">
+        <pc:chgData name="Tavian Nguyen" userId="S::tavian.n@itcgroup.io::aa81296b-9269-404a-b3a4-a824e4f2ee15" providerId="AD" clId="Web-{77F4BD5E-CA64-1597-1257-D40010619267}" dt="2026-10-16T03:17:34.298" v="77" actId="1076"/>
+        <pc:sldMkLst>
+          <pc:docMk/>
+          <pc:sldMk cId="0" sldId="266"/>
+        </pc:sldMkLst>
+        <pc:spChg chg="mod">
+          <ac:chgData name="Tavian Nguyen" userId="S::tavian.n@itcgroup.io::aa81296b-9269-404a-b3a4-a824e4f2ee15" providerId="AD" clId="Web-{77F4BD5E-CA64-1597-1257-D40010619267}" dt="2026-10-16T02:59:14.290" v="75" actId="20577"/>
+          <ac:spMkLst>
+            <pc:docMk/>
+            <pc:sldMk cId="0" sldId="266"/>
+            <ac:spMk id="56" creationId="{00000000-0000-0000-0000-000000000000}"/>
+          </ac:spMkLst>
+        </pc:spChg>
+        <pc:spChg chg="mod">
+          <ac:chgData name="Tavian Nguyen" userId="S::tavian.n@itcgroup.io::aa81296b-9269-404a-b3a4-a824e4f2ee15" providerId="AD" clId="Web-{77F4BD5E-CA64-1597-1257-D40010619267}" dt="2026-10-16T03:17:34.298" v="77" actId="1076"/>
+          <ac:spMkLst>
+            <pc:docMk/>
+            <pc:sldMk cId="0" sldId="266"/>
+            <ac:spMk id="59" creationId="{00000000-0000-0000-0000-000000000000}"/>
+          </ac:spMkLst>
+        </pc:spChg>
+      </pc:sldChg>
+      <pc:sldChg chg="modSp">
+        <pc:chgData name="Tavian Nguyen" userId="S::tavian.n@itcgroup.io::aa81296b-9269-404a-b3a4-a824e4f2ee15" providerId="AD" clId="Web-{77F4BD5E-CA64-1597-1257-D40010619267}" dt="2026-10-16T03:18:13.877" v="83" actId="20577"/>
+        <pc:sldMkLst>
+          <pc:docMk/>
+          <pc:sldMk cId="0" sldId="267"/>
+        </pc:sldMkLst>
+        <pc:spChg chg="mod">
+          <ac:chgData name="Tavian Nguyen" userId="S::tavian.n@itcgroup.io::aa81296b-9269-404a-b3a4-a824e4f2ee15" providerId="AD" clId="Web-{77F4BD5E-CA64-1597-1257-D40010619267}" dt="2026-10-16T03:18:13.877" v="83" actId="20577"/>
+          <ac:spMkLst>
+            <pc:docMk/>
+            <pc:sldMk cId="0" sldId="267"/>
+            <ac:spMk id="4" creationId="{00000000-0000-0000-0000-000000000000}"/>
+          </ac:spMkLst>
+        </pc:spChg>
+      </pc:sldChg>
+    </pc:docChg>
+  </pc:docChgLst>
+</pc:chgInfo>
+</file>
+
 <file path=ppt/slideLayouts/slideLayout1.xml><?xml version="1.0" encoding="utf-8"?>
 <p:sldLayout xmlns:a="http://schemas.openxmlformats.org/drawingml/2006/main" xmlns:r="http://schemas.openxmlformats.org/officeDocument/2006/relationships" xmlns:p="http://schemas.openxmlformats.org/presentationml/2006/main" type="blank" preserve="1">
   <p:cSld name="realtime_web — Blank">
@@ -168,7 +388,7 @@
           <a:p>
             <a:fld id="{5BCAD085-E8A6-8845-BD4E-CB4CCA059FC4}" type="datetimeFigureOut">
               <a:rPr lang="en" smtClean="0"/>
-              <a:t>10/7/2026</a:t>
+              <a:t>10/15/2026</a:t>
             </a:fld>
             <a:endParaRPr lang="en"/>
           </a:p>
@@ -281,7 +501,7 @@
           <a:p>
             <a:fld id="{5BCAD085-E8A6-8845-BD4E-CB4CCA059FC4}" type="datetimeFigureOut">
               <a:rPr lang="en" smtClean="0"/>
-              <a:t>10/7/2026</a:t>
+              <a:t>10/15/2026</a:t>
             </a:fld>
             <a:endParaRPr lang="en"/>
           </a:p>
@@ -723,7 +943,7 @@
                 </a:lnSpc>
               </a:pPr>
               <a:r>
-                <a:rPr lang="en" sz="5400" b="1" dirty="0">
+                <a:rPr lang="en" sz="5400" b="1">
                   <a:solidFill>
                     <a:schemeClr val="accent1"/>
                   </a:solidFill>
@@ -734,7 +954,7 @@
                 <a:t>Real-time</a:t>
               </a:r>
               <a:br>
-                <a:rPr lang="en" sz="5400" b="1" dirty="0">
+                <a:rPr lang="en" sz="5400" b="1">
                   <a:solidFill>
                     <a:schemeClr val="accent1"/>
                   </a:solidFill>
@@ -744,7 +964,7 @@
                 </a:rPr>
               </a:br>
               <a:r>
-                <a:rPr lang="en" sz="5400" b="1" dirty="0">
+                <a:rPr lang="en" sz="5400" b="1">
                   <a:solidFill>
                     <a:schemeClr val="accent1"/>
                   </a:solidFill>
@@ -755,7 +975,7 @@
                 <a:t>Communication</a:t>
               </a:r>
               <a:br>
-                <a:rPr lang="en" sz="5400" b="1" dirty="0">
+                <a:rPr lang="en" sz="5400" b="1">
                   <a:solidFill>
                     <a:schemeClr val="accent1"/>
                   </a:solidFill>
@@ -765,7 +985,7 @@
                 </a:rPr>
               </a:br>
               <a:r>
-                <a:rPr lang="en" sz="5400" b="1" dirty="0">
+                <a:rPr lang="en" sz="5400" b="1">
                   <a:solidFill>
                     <a:schemeClr val="accent1"/>
                   </a:solidFill>
@@ -983,7 +1203,7 @@
             <a:p>
               <a:pPr algn="ctr"/>
               <a:r>
-                <a:rPr lang="en" sz="2100" dirty="0">
+                <a:rPr lang="en" sz="2100">
                   <a:solidFill>
                     <a:schemeClr val="accent1"/>
                   </a:solidFill>
@@ -1114,7 +1334,7 @@
             <a:p>
               <a:pPr algn="ctr"/>
               <a:r>
-                <a:rPr lang="en" sz="2100" dirty="0">
+                <a:rPr lang="en" sz="2100">
                   <a:solidFill>
                     <a:srgbClr val="FFFFFF"/>
                   </a:solidFill>
@@ -1169,7 +1389,7 @@
             <a:p>
               <a:pPr algn="l"/>
               <a:r>
-                <a:rPr lang="en" sz="2400" dirty="0">
+                <a:rPr lang="en" sz="2400">
                   <a:solidFill>
                     <a:schemeClr val="accent5"/>
                   </a:solidFill>
@@ -1224,7 +1444,7 @@
             <a:p>
               <a:pPr algn="l"/>
               <a:r>
-                <a:rPr lang="en" sz="1050" dirty="0">
+                <a:rPr lang="en" sz="1050">
                   <a:solidFill>
                     <a:schemeClr val="accent5"/>
                   </a:solidFill>
@@ -1264,7 +1484,7 @@
             <a:p>
               <a:pPr algn="r"/>
               <a:r>
-                <a:rPr lang="en" sz="1050" dirty="0">
+                <a:rPr lang="en" sz="1050">
                   <a:solidFill>
                     <a:schemeClr val="accent5"/>
                   </a:solidFill>
@@ -1364,7 +1584,7 @@
             <a:p>
               <a:pPr algn="l"/>
               <a:r>
-                <a:rPr lang="en" sz="2400" b="1" dirty="0">
+                <a:rPr lang="en" sz="2400" b="1">
                   <a:solidFill>
                     <a:schemeClr val="accent2"/>
                   </a:solidFill>
@@ -1404,7 +1624,7 @@
             <a:p>
               <a:pPr algn="l"/>
               <a:r>
-                <a:rPr lang="en" sz="3600" b="1" dirty="0">
+                <a:rPr lang="en" sz="3600" b="1">
                   <a:solidFill>
                     <a:schemeClr val="accent1"/>
                   </a:solidFill>
@@ -1711,7 +1931,7 @@
             <a:p>
               <a:pPr algn="ctr"/>
               <a:r>
-                <a:rPr lang="en" sz="2400" b="1" dirty="0">
+                <a:rPr lang="en" sz="2400" b="1">
                   <a:solidFill>
                     <a:schemeClr val="accent1"/>
                   </a:solidFill>
@@ -1751,7 +1971,7 @@
             <a:p>
               <a:pPr algn="ctr"/>
               <a:r>
-                <a:rPr lang="en" sz="2100" dirty="0">
+                <a:rPr lang="en" sz="2100">
                   <a:solidFill>
                     <a:schemeClr val="accent5"/>
                   </a:solidFill>
@@ -1954,7 +2174,7 @@
             <a:p>
               <a:pPr algn="ctr"/>
               <a:r>
-                <a:rPr lang="en" sz="2400" b="1" dirty="0">
+                <a:rPr lang="en" sz="2400" b="1">
                   <a:solidFill>
                     <a:schemeClr val="accent1"/>
                   </a:solidFill>
@@ -1994,7 +2214,7 @@
             <a:p>
               <a:pPr algn="ctr"/>
               <a:r>
-                <a:rPr lang="en" sz="2100" dirty="0">
+                <a:rPr lang="en" sz="2100">
                   <a:solidFill>
                     <a:schemeClr val="accent5"/>
                   </a:solidFill>
@@ -2251,7 +2471,7 @@
             <a:p>
               <a:pPr algn="ctr"/>
               <a:r>
-                <a:rPr lang="en" sz="2400" b="1" dirty="0">
+                <a:rPr lang="en" sz="2400" b="1">
                   <a:solidFill>
                     <a:schemeClr val="accent1"/>
                   </a:solidFill>
@@ -2291,7 +2511,7 @@
             <a:p>
               <a:pPr algn="ctr"/>
               <a:r>
-                <a:rPr lang="en" sz="2100" dirty="0">
+                <a:rPr lang="en" sz="2100">
                   <a:solidFill>
                     <a:schemeClr val="accent5"/>
                   </a:solidFill>
@@ -2377,7 +2597,7 @@
             <a:p>
               <a:pPr algn="l"/>
               <a:r>
-                <a:rPr lang="en" sz="2400" b="1" dirty="0">
+                <a:rPr lang="en" sz="2400" b="1">
                   <a:solidFill>
                     <a:srgbClr val="FFFFFF"/>
                   </a:solidFill>
@@ -2417,7 +2637,7 @@
             <a:p>
               <a:pPr algn="l"/>
               <a:r>
-                <a:rPr lang="en" sz="2100" dirty="0">
+                <a:rPr lang="en" sz="2100">
                   <a:solidFill>
                     <a:srgbClr val="FFFFFF"/>
                   </a:solidFill>
@@ -2472,7 +2692,7 @@
             <a:p>
               <a:pPr algn="l"/>
               <a:r>
-                <a:rPr lang="en" sz="1050" dirty="0">
+                <a:rPr lang="en" sz="1050">
                   <a:solidFill>
                     <a:schemeClr val="accent5"/>
                   </a:solidFill>
@@ -2512,7 +2732,7 @@
             <a:p>
               <a:pPr algn="r"/>
               <a:r>
-                <a:rPr lang="en" sz="1050" dirty="0">
+                <a:rPr lang="en" sz="1050">
                   <a:solidFill>
                     <a:schemeClr val="accent5"/>
                   </a:solidFill>
@@ -2612,7 +2832,7 @@
             <a:p>
               <a:pPr algn="l"/>
               <a:r>
-                <a:rPr lang="en" sz="2400" b="1" dirty="0">
+                <a:rPr lang="en" sz="2400" b="1">
                   <a:solidFill>
                     <a:schemeClr val="accent2"/>
                   </a:solidFill>
@@ -2652,7 +2872,7 @@
             <a:p>
               <a:pPr algn="l"/>
               <a:r>
-                <a:rPr lang="en" sz="3600" b="1" dirty="0">
+                <a:rPr lang="en" sz="3600" b="1">
                   <a:solidFill>
                     <a:schemeClr val="accent1"/>
                   </a:solidFill>
@@ -2668,46 +2888,46 @@
       </p:grpSp>
       <p:grpSp>
         <p:nvGrpSpPr>
-          <p:cNvPr id="16" name="choices"/>
+          <p:cNvPr id="53" name="choices"/>
           <p:cNvGrpSpPr/>
           <p:nvPr/>
         </p:nvGrpSpPr>
         <p:grpSpPr>
           <a:xfrm>
-            <a:off x="597408" y="2279650"/>
-            <a:ext cx="6327267" cy="2298192"/>
-            <a:chOff x="597408" y="2279650"/>
-            <a:chExt cx="6327267" cy="2298192"/>
+            <a:off x="609600" y="2163743"/>
+            <a:ext cx="5962650" cy="2867025"/>
+            <a:chOff x="609600" y="2163743"/>
+            <a:chExt cx="5962650" cy="2867025"/>
           </a:xfrm>
         </p:grpSpPr>
         <p:sp>
           <p:nvSpPr>
-            <p:cNvPr id="5" name="TextBox 5"/>
-            <p:cNvSpPr txBox="1"/>
-            <p:nvPr/>
-          </p:nvSpPr>
-          <p:spPr>
-            <a:xfrm>
-              <a:off x="597408" y="2279650"/>
-              <a:ext cx="2412420" cy="469392"/>
-            </a:xfrm>
-            <a:prstGeom prst="rect">
-              <a:avLst/>
-            </a:prstGeom>
-            <a:noFill/>
-            <a:ln>
-              <a:noFill/>
-            </a:ln>
-          </p:spPr>
-          <p:txBody>
-            <a:bodyPr wrap="none" lIns="0" tIns="0" rIns="0" bIns="0" anchor="t" anchorCtr="0">
+            <p:cNvPr id="34" name="Need 1"/>
+            <p:cNvSpPr txBox="1"/>
+            <p:nvPr/>
+          </p:nvSpPr>
+          <p:spPr>
+            <a:xfrm>
+              <a:off x="609600" y="2163743"/>
+              <a:ext cx="2857500" cy="466725"/>
+            </a:xfrm>
+            <a:prstGeom prst="rect">
+              <a:avLst/>
+            </a:prstGeom>
+            <a:noFill/>
+            <a:ln>
+              <a:noFill/>
+            </a:ln>
+          </p:spPr>
+          <p:txBody>
+            <a:bodyPr wrap="square" lIns="0" tIns="0" rIns="0" bIns="0" anchor="t" anchorCtr="0">
               <a:spAutoFit/>
             </a:bodyPr>
             <a:lstStyle/>
             <a:p>
               <a:pPr algn="l"/>
               <a:r>
-                <a:rPr lang="en" sz="2400" dirty="0">
+                <a:rPr lang="en" sz="2400">
                   <a:solidFill>
                     <a:schemeClr val="accent5"/>
                   </a:solidFill>
@@ -2722,14 +2942,14 @@
         </p:sp>
         <p:sp>
           <p:nvSpPr>
-            <p:cNvPr id="6" name="Line 6"/>
+            <p:cNvPr id="35" name="Arrow 1"/>
             <p:cNvSpPr/>
             <p:nvPr/>
           </p:nvSpPr>
           <p:spPr>
             <a:xfrm>
-              <a:off x="3362325" y="2476500"/>
-              <a:ext cx="742950" cy="1"/>
+              <a:off x="3543300" y="2363768"/>
+              <a:ext cx="666750" cy="0"/>
             </a:xfrm>
             <a:prstGeom prst="line">
               <a:avLst/>
@@ -2752,32 +2972,32 @@
         </p:sp>
         <p:sp>
           <p:nvSpPr>
-            <p:cNvPr id="7" name="TextBox 7"/>
-            <p:cNvSpPr txBox="1"/>
-            <p:nvPr/>
-          </p:nvSpPr>
-          <p:spPr>
-            <a:xfrm>
-              <a:off x="4464558" y="2279650"/>
-              <a:ext cx="1099945" cy="469392"/>
-            </a:xfrm>
-            <a:prstGeom prst="rect">
-              <a:avLst/>
-            </a:prstGeom>
-            <a:noFill/>
-            <a:ln>
-              <a:noFill/>
-            </a:ln>
-          </p:spPr>
-          <p:txBody>
-            <a:bodyPr wrap="none" lIns="0" tIns="0" rIns="0" bIns="0" anchor="t" anchorCtr="0">
+            <p:cNvPr id="36" name="Method 1"/>
+            <p:cNvSpPr txBox="1"/>
+            <p:nvPr/>
+          </p:nvSpPr>
+          <p:spPr>
+            <a:xfrm>
+              <a:off x="4419600" y="2163743"/>
+              <a:ext cx="2152650" cy="466725"/>
+            </a:xfrm>
+            <a:prstGeom prst="rect">
+              <a:avLst/>
+            </a:prstGeom>
+            <a:noFill/>
+            <a:ln>
+              <a:noFill/>
+            </a:ln>
+          </p:spPr>
+          <p:txBody>
+            <a:bodyPr wrap="square" lIns="0" tIns="0" rIns="0" bIns="0" anchor="t" anchorCtr="0">
               <a:spAutoFit/>
             </a:bodyPr>
             <a:lstStyle/>
             <a:p>
               <a:pPr algn="l"/>
               <a:r>
-                <a:rPr lang="en" sz="2400" b="1" dirty="0">
+                <a:rPr lang="en" sz="2400" b="1">
                   <a:solidFill>
                     <a:schemeClr val="accent1"/>
                   </a:solidFill>
@@ -2792,32 +3012,18 @@
         </p:sp>
         <p:sp>
           <p:nvSpPr>
-            <p:cNvPr id="8" name="Line 8"/>
+            <p:cNvPr id="38" name="Divider 1"/>
             <p:cNvSpPr/>
             <p:nvPr/>
           </p:nvSpPr>
           <p:spPr>
             <a:xfrm>
-              <a:off x="609600" y="2952750"/>
-              <a:ext cx="6315075" cy="9525"/>
-            </a:xfrm>
-            <a:custGeom>
-              <a:avLst/>
-              <a:gdLst/>
-              <a:ahLst/>
-              <a:cxnLst/>
-              <a:rect l="l" t="t" r="r" b="b"/>
-              <a:pathLst>
-                <a:path w="6315075" h="9525">
-                  <a:moveTo>
-                    <a:pt x="0" y="0"/>
-                  </a:moveTo>
-                  <a:lnTo>
-                    <a:pt x="6315075" y="0"/>
-                  </a:lnTo>
-                </a:path>
-              </a:pathLst>
-            </a:custGeom>
+              <a:off x="609600" y="2800350"/>
+              <a:ext cx="5962650" cy="0"/>
+            </a:xfrm>
+            <a:prstGeom prst="line">
+              <a:avLst/>
+            </a:prstGeom>
             <a:noFill/>
             <a:ln w="9525">
               <a:solidFill>
@@ -2835,32 +3041,32 @@
         </p:sp>
         <p:sp>
           <p:nvSpPr>
-            <p:cNvPr id="9" name="TextBox 9"/>
-            <p:cNvSpPr txBox="1"/>
-            <p:nvPr/>
-          </p:nvSpPr>
-          <p:spPr>
-            <a:xfrm>
-              <a:off x="597408" y="3194050"/>
-              <a:ext cx="1704041" cy="469392"/>
-            </a:xfrm>
-            <a:prstGeom prst="rect">
-              <a:avLst/>
-            </a:prstGeom>
-            <a:noFill/>
-            <a:ln>
-              <a:noFill/>
-            </a:ln>
-          </p:spPr>
-          <p:txBody>
-            <a:bodyPr wrap="none" lIns="0" tIns="0" rIns="0" bIns="0" anchor="t" anchorCtr="0">
+            <p:cNvPr id="39" name="Need 2"/>
+            <p:cNvSpPr txBox="1"/>
+            <p:nvPr/>
+          </p:nvSpPr>
+          <p:spPr>
+            <a:xfrm>
+              <a:off x="609600" y="2963843"/>
+              <a:ext cx="2857500" cy="466725"/>
+            </a:xfrm>
+            <a:prstGeom prst="rect">
+              <a:avLst/>
+            </a:prstGeom>
+            <a:noFill/>
+            <a:ln>
+              <a:noFill/>
+            </a:ln>
+          </p:spPr>
+          <p:txBody>
+            <a:bodyPr wrap="square" lIns="0" tIns="0" rIns="0" bIns="0" anchor="t" anchorCtr="0">
               <a:spAutoFit/>
             </a:bodyPr>
             <a:lstStyle/>
             <a:p>
               <a:pPr algn="l"/>
               <a:r>
-                <a:rPr lang="en" sz="2400" dirty="0">
+                <a:rPr lang="en" sz="2400">
                   <a:solidFill>
                     <a:schemeClr val="accent5"/>
                   </a:solidFill>
@@ -2868,21 +3074,21 @@
                   <a:ea typeface="+mn-ea"/>
                   <a:cs typeface="+mn-cs"/>
                 </a:rPr>
-                <a:t>Server push</a:t>
-              </a:r>
-            </a:p>
-          </p:txBody>
-        </p:sp>
-        <p:sp>
-          <p:nvSpPr>
-            <p:cNvPr id="10" name="Line 10"/>
+                <a:t>Earlier updates</a:t>
+              </a:r>
+            </a:p>
+          </p:txBody>
+        </p:sp>
+        <p:sp>
+          <p:nvSpPr>
+            <p:cNvPr id="40" name="Arrow 2"/>
             <p:cNvSpPr/>
             <p:nvPr/>
           </p:nvSpPr>
           <p:spPr>
             <a:xfrm>
-              <a:off x="3362325" y="3390900"/>
-              <a:ext cx="742950" cy="1"/>
+              <a:off x="3543300" y="3163868"/>
+              <a:ext cx="666750" cy="0"/>
             </a:xfrm>
             <a:prstGeom prst="line">
               <a:avLst/>
@@ -2905,72 +3111,58 @@
         </p:sp>
         <p:sp>
           <p:nvSpPr>
-            <p:cNvPr id="11" name="TextBox 11"/>
-            <p:cNvSpPr txBox="1"/>
-            <p:nvPr/>
-          </p:nvSpPr>
-          <p:spPr>
-            <a:xfrm>
-              <a:off x="4464558" y="3194050"/>
-              <a:ext cx="588747" cy="469392"/>
-            </a:xfrm>
-            <a:prstGeom prst="rect">
-              <a:avLst/>
-            </a:prstGeom>
-            <a:noFill/>
-            <a:ln>
-              <a:noFill/>
-            </a:ln>
-          </p:spPr>
-          <p:txBody>
-            <a:bodyPr wrap="none" lIns="0" tIns="0" rIns="0" bIns="0" anchor="t" anchorCtr="0">
+            <p:cNvPr id="41" name="Method 2"/>
+            <p:cNvSpPr txBox="1"/>
+            <p:nvPr/>
+          </p:nvSpPr>
+          <p:spPr>
+            <a:xfrm>
+              <a:off x="4419600" y="2963843"/>
+              <a:ext cx="2152650" cy="466725"/>
+            </a:xfrm>
+            <a:prstGeom prst="rect">
+              <a:avLst/>
+            </a:prstGeom>
+            <a:noFill/>
+            <a:ln>
+              <a:noFill/>
+            </a:ln>
+          </p:spPr>
+          <p:txBody>
+            <a:bodyPr wrap="square" lIns="0" tIns="0" rIns="0" bIns="0" anchor="t" anchorCtr="0">
               <a:spAutoFit/>
             </a:bodyPr>
             <a:lstStyle/>
             <a:p>
               <a:pPr algn="l"/>
               <a:r>
-                <a:rPr lang="en" sz="2400" b="1" dirty="0">
-                  <a:solidFill>
-                    <a:schemeClr val="accent2"/>
-                  </a:solidFill>
-                  <a:latin typeface="+mn-lt"/>
-                  <a:ea typeface="+mn-ea"/>
-                  <a:cs typeface="+mn-cs"/>
-                </a:rPr>
-                <a:t>SSE</a:t>
-              </a:r>
-            </a:p>
-          </p:txBody>
-        </p:sp>
-        <p:sp>
-          <p:nvSpPr>
-            <p:cNvPr id="12" name="Line 12"/>
+                <a:rPr lang="en" sz="2400" b="1">
+                  <a:solidFill>
+                    <a:schemeClr val="accent1"/>
+                  </a:solidFill>
+                  <a:latin typeface="+mn-lt"/>
+                  <a:ea typeface="+mn-ea"/>
+                  <a:cs typeface="+mn-cs"/>
+                </a:rPr>
+                <a:t>Long polling</a:t>
+              </a:r>
+            </a:p>
+          </p:txBody>
+        </p:sp>
+        <p:sp>
+          <p:nvSpPr>
+            <p:cNvPr id="43" name="Divider 2"/>
             <p:cNvSpPr/>
             <p:nvPr/>
           </p:nvSpPr>
           <p:spPr>
             <a:xfrm>
-              <a:off x="609600" y="3867150"/>
-              <a:ext cx="6315075" cy="9525"/>
-            </a:xfrm>
-            <a:custGeom>
-              <a:avLst/>
-              <a:gdLst/>
-              <a:ahLst/>
-              <a:cxnLst/>
-              <a:rect l="l" t="t" r="r" b="b"/>
-              <a:pathLst>
-                <a:path w="6315075" h="9525">
-                  <a:moveTo>
-                    <a:pt x="0" y="0"/>
-                  </a:moveTo>
-                  <a:lnTo>
-                    <a:pt x="6315075" y="0"/>
-                  </a:lnTo>
-                </a:path>
-              </a:pathLst>
-            </a:custGeom>
+              <a:off x="609600" y="3600450"/>
+              <a:ext cx="5962650" cy="0"/>
+            </a:xfrm>
+            <a:prstGeom prst="line">
+              <a:avLst/>
+            </a:prstGeom>
             <a:noFill/>
             <a:ln w="9525">
               <a:solidFill>
@@ -2988,32 +3180,32 @@
         </p:sp>
         <p:sp>
           <p:nvSpPr>
-            <p:cNvPr id="13" name="TextBox 13"/>
-            <p:cNvSpPr txBox="1"/>
-            <p:nvPr/>
-          </p:nvSpPr>
-          <p:spPr>
-            <a:xfrm>
-              <a:off x="597408" y="4108450"/>
-              <a:ext cx="1516743" cy="469392"/>
-            </a:xfrm>
-            <a:prstGeom prst="rect">
-              <a:avLst/>
-            </a:prstGeom>
-            <a:noFill/>
-            <a:ln>
-              <a:noFill/>
-            </a:ln>
-          </p:spPr>
-          <p:txBody>
-            <a:bodyPr wrap="none" lIns="0" tIns="0" rIns="0" bIns="0" anchor="t" anchorCtr="0">
+            <p:cNvPr id="44" name="Need 3"/>
+            <p:cNvSpPr txBox="1"/>
+            <p:nvPr/>
+          </p:nvSpPr>
+          <p:spPr>
+            <a:xfrm>
+              <a:off x="609600" y="3763943"/>
+              <a:ext cx="2857500" cy="466725"/>
+            </a:xfrm>
+            <a:prstGeom prst="rect">
+              <a:avLst/>
+            </a:prstGeom>
+            <a:noFill/>
+            <a:ln>
+              <a:noFill/>
+            </a:ln>
+          </p:spPr>
+          <p:txBody>
+            <a:bodyPr wrap="square" lIns="0" tIns="0" rIns="0" bIns="0" anchor="t" anchorCtr="0">
               <a:spAutoFit/>
             </a:bodyPr>
             <a:lstStyle/>
             <a:p>
               <a:pPr algn="l"/>
               <a:r>
-                <a:rPr lang="en" sz="2400" dirty="0">
+                <a:rPr lang="en" sz="2400">
                   <a:solidFill>
                     <a:schemeClr val="accent5"/>
                   </a:solidFill>
@@ -3021,21 +3213,21 @@
                   <a:ea typeface="+mn-ea"/>
                   <a:cs typeface="+mn-cs"/>
                 </a:rPr>
-                <a:t>Interactive</a:t>
-              </a:r>
-            </a:p>
-          </p:txBody>
-        </p:sp>
-        <p:sp>
-          <p:nvSpPr>
-            <p:cNvPr id="14" name="Line 14"/>
+                <a:t>Server push</a:t>
+              </a:r>
+            </a:p>
+          </p:txBody>
+        </p:sp>
+        <p:sp>
+          <p:nvSpPr>
+            <p:cNvPr id="45" name="Arrow 3"/>
             <p:cNvSpPr/>
             <p:nvPr/>
           </p:nvSpPr>
           <p:spPr>
             <a:xfrm>
-              <a:off x="3362325" y="4305300"/>
-              <a:ext cx="742950" cy="1"/>
+              <a:off x="3543300" y="3963968"/>
+              <a:ext cx="666750" cy="0"/>
             </a:xfrm>
             <a:prstGeom prst="line">
               <a:avLst/>
@@ -3058,32 +3250,171 @@
         </p:sp>
         <p:sp>
           <p:nvSpPr>
-            <p:cNvPr id="15" name="TextBox 15"/>
-            <p:cNvSpPr txBox="1"/>
-            <p:nvPr/>
-          </p:nvSpPr>
-          <p:spPr>
-            <a:xfrm>
-              <a:off x="4464558" y="4108450"/>
-              <a:ext cx="1760612" cy="469392"/>
-            </a:xfrm>
-            <a:prstGeom prst="rect">
-              <a:avLst/>
-            </a:prstGeom>
-            <a:noFill/>
-            <a:ln>
-              <a:noFill/>
-            </a:ln>
-          </p:spPr>
-          <p:txBody>
-            <a:bodyPr wrap="none" lIns="0" tIns="0" rIns="0" bIns="0" anchor="t" anchorCtr="0">
+            <p:cNvPr id="46" name="Method 3"/>
+            <p:cNvSpPr txBox="1"/>
+            <p:nvPr/>
+          </p:nvSpPr>
+          <p:spPr>
+            <a:xfrm>
+              <a:off x="4419600" y="3763943"/>
+              <a:ext cx="2152650" cy="466725"/>
+            </a:xfrm>
+            <a:prstGeom prst="rect">
+              <a:avLst/>
+            </a:prstGeom>
+            <a:noFill/>
+            <a:ln>
+              <a:noFill/>
+            </a:ln>
+          </p:spPr>
+          <p:txBody>
+            <a:bodyPr wrap="square" lIns="0" tIns="0" rIns="0" bIns="0" anchor="t" anchorCtr="0">
               <a:spAutoFit/>
             </a:bodyPr>
             <a:lstStyle/>
             <a:p>
               <a:pPr algn="l"/>
               <a:r>
-                <a:rPr lang="en" sz="2400" b="1" dirty="0">
+                <a:rPr lang="en" sz="2400" b="1">
+                  <a:solidFill>
+                    <a:schemeClr val="accent2"/>
+                  </a:solidFill>
+                  <a:latin typeface="+mn-lt"/>
+                  <a:ea typeface="+mn-ea"/>
+                  <a:cs typeface="+mn-cs"/>
+                </a:rPr>
+                <a:t>SSE</a:t>
+              </a:r>
+            </a:p>
+          </p:txBody>
+        </p:sp>
+        <p:sp>
+          <p:nvSpPr>
+            <p:cNvPr id="48" name="Divider 3"/>
+            <p:cNvSpPr/>
+            <p:nvPr/>
+          </p:nvSpPr>
+          <p:spPr>
+            <a:xfrm>
+              <a:off x="609600" y="4400550"/>
+              <a:ext cx="5962650" cy="0"/>
+            </a:xfrm>
+            <a:prstGeom prst="line">
+              <a:avLst/>
+            </a:prstGeom>
+            <a:noFill/>
+            <a:ln w="9525">
+              <a:solidFill>
+                <a:schemeClr val="accent6"/>
+              </a:solidFill>
+            </a:ln>
+          </p:spPr>
+          <p:txBody>
+            <a:bodyPr/>
+            <a:lstStyle/>
+            <a:p>
+              <a:endParaRPr lang="en-150"/>
+            </a:p>
+          </p:txBody>
+        </p:sp>
+        <p:sp>
+          <p:nvSpPr>
+            <p:cNvPr id="49" name="Need 4"/>
+            <p:cNvSpPr txBox="1"/>
+            <p:nvPr/>
+          </p:nvSpPr>
+          <p:spPr>
+            <a:xfrm>
+              <a:off x="609600" y="4564043"/>
+              <a:ext cx="2857500" cy="466725"/>
+            </a:xfrm>
+            <a:prstGeom prst="rect">
+              <a:avLst/>
+            </a:prstGeom>
+            <a:noFill/>
+            <a:ln>
+              <a:noFill/>
+            </a:ln>
+          </p:spPr>
+          <p:txBody>
+            <a:bodyPr wrap="square" lIns="0" tIns="0" rIns="0" bIns="0" anchor="t" anchorCtr="0">
+              <a:spAutoFit/>
+            </a:bodyPr>
+            <a:lstStyle/>
+            <a:p>
+              <a:pPr algn="l"/>
+              <a:r>
+                <a:rPr lang="en" sz="2400">
+                  <a:solidFill>
+                    <a:schemeClr val="accent5"/>
+                  </a:solidFill>
+                  <a:latin typeface="+mn-lt"/>
+                  <a:ea typeface="+mn-ea"/>
+                  <a:cs typeface="+mn-cs"/>
+                </a:rPr>
+                <a:t>Two-way interaction</a:t>
+              </a:r>
+            </a:p>
+          </p:txBody>
+        </p:sp>
+        <p:sp>
+          <p:nvSpPr>
+            <p:cNvPr id="50" name="Arrow 4"/>
+            <p:cNvSpPr/>
+            <p:nvPr/>
+          </p:nvSpPr>
+          <p:spPr>
+            <a:xfrm>
+              <a:off x="3543300" y="4764068"/>
+              <a:ext cx="666750" cy="0"/>
+            </a:xfrm>
+            <a:prstGeom prst="line">
+              <a:avLst/>
+            </a:prstGeom>
+            <a:noFill/>
+            <a:ln w="19050">
+              <a:solidFill>
+                <a:schemeClr val="accent2"/>
+              </a:solidFill>
+              <a:tailEnd type="triangle" w="lg" len="lg"/>
+            </a:ln>
+          </p:spPr>
+          <p:txBody>
+            <a:bodyPr/>
+            <a:lstStyle/>
+            <a:p>
+              <a:endParaRPr lang="en-150"/>
+            </a:p>
+          </p:txBody>
+        </p:sp>
+        <p:sp>
+          <p:nvSpPr>
+            <p:cNvPr id="51" name="Method 4"/>
+            <p:cNvSpPr txBox="1"/>
+            <p:nvPr/>
+          </p:nvSpPr>
+          <p:spPr>
+            <a:xfrm>
+              <a:off x="4419600" y="4564043"/>
+              <a:ext cx="2152650" cy="466725"/>
+            </a:xfrm>
+            <a:prstGeom prst="rect">
+              <a:avLst/>
+            </a:prstGeom>
+            <a:noFill/>
+            <a:ln>
+              <a:noFill/>
+            </a:ln>
+          </p:spPr>
+          <p:txBody>
+            <a:bodyPr wrap="square" lIns="0" tIns="0" rIns="0" bIns="0" anchor="t" anchorCtr="0">
+              <a:spAutoFit/>
+            </a:bodyPr>
+            <a:lstStyle/>
+            <a:p>
+              <a:pPr algn="l"/>
+              <a:r>
+                <a:rPr lang="en" sz="2400" b="1">
                   <a:solidFill>
                     <a:schemeClr val="accent2"/>
                   </a:solidFill>
@@ -3099,32 +3430,32 @@
       </p:grpSp>
       <p:grpSp>
         <p:nvGrpSpPr>
-          <p:cNvPr id="28" name="guardrails"/>
+          <p:cNvPr id="60" name="guardrails"/>
           <p:cNvGrpSpPr/>
           <p:nvPr/>
         </p:nvGrpSpPr>
         <p:grpSpPr>
           <a:xfrm>
-            <a:off x="7620000" y="2095500"/>
-            <a:ext cx="3962400" cy="2876550"/>
-            <a:chOff x="7620000" y="2095500"/>
-            <a:chExt cx="3962400" cy="2876550"/>
+            <a:off x="7048500" y="2038350"/>
+            <a:ext cx="4533900" cy="3114675"/>
+            <a:chOff x="7048500" y="2038350"/>
+            <a:chExt cx="4533900" cy="3114675"/>
           </a:xfrm>
         </p:grpSpPr>
         <p:sp>
           <p:nvSpPr>
-            <p:cNvPr id="17" name="Rectangle 17"/>
+            <p:cNvPr id="54" name="Best practice card"/>
             <p:cNvSpPr/>
             <p:nvPr/>
           </p:nvSpPr>
           <p:spPr>
             <a:xfrm>
-              <a:off x="7620000" y="2095500"/>
-              <a:ext cx="3962400" cy="2876550"/>
+              <a:off x="7048500" y="2038350"/>
+              <a:ext cx="4533900" cy="1495425"/>
             </a:xfrm>
             <a:prstGeom prst="roundRect">
               <a:avLst>
-                <a:gd name="adj" fmla="val 3974"/>
+                <a:gd name="adj" fmla="val 7643"/>
               </a:avLst>
             </a:prstGeom>
             <a:solidFill>
@@ -3142,463 +3473,314 @@
             </a:p>
           </p:txBody>
         </p:sp>
-        <p:grpSp>
-          <p:nvGrpSpPr>
-            <p:cNvPr id="20" name="Group 20"/>
-            <p:cNvGrpSpPr/>
-            <p:nvPr/>
-          </p:nvGrpSpPr>
-          <p:grpSpPr>
-            <a:xfrm>
-              <a:off x="7985125" y="2473856"/>
-              <a:ext cx="241299" cy="252937"/>
-              <a:chOff x="7985125" y="2473856"/>
-              <a:chExt cx="241299" cy="252937"/>
-            </a:xfrm>
-          </p:grpSpPr>
-          <p:sp>
-            <p:nvSpPr>
-              <p:cNvPr id="18" name="Freeform 18"/>
-              <p:cNvSpPr/>
-              <p:nvPr/>
-            </p:nvSpPr>
-            <p:spPr>
-              <a:xfrm>
-                <a:off x="7985125" y="2473856"/>
-                <a:ext cx="241299" cy="111387"/>
-              </a:xfrm>
-              <a:custGeom>
-                <a:avLst/>
-                <a:gdLst/>
-                <a:ahLst/>
-                <a:cxnLst/>
-                <a:rect l="l" t="t" r="r" b="b"/>
-                <a:pathLst>
-                  <a:path w="241299" h="111387">
-                    <a:moveTo>
-                      <a:pt x="241299" y="111387"/>
-                    </a:moveTo>
-                    <a:cubicBezTo>
-                      <a:pt x="233718" y="56832"/>
-                      <a:pt x="190564" y="14097"/>
-                      <a:pt x="135937" y="7049"/>
-                    </a:cubicBezTo>
-                    <a:cubicBezTo>
-                      <a:pt x="81310" y="0"/>
-                      <a:pt x="28722" y="30381"/>
-                      <a:pt x="7541" y="81225"/>
-                    </a:cubicBezTo>
-                    <a:moveTo>
-                      <a:pt x="0" y="20900"/>
-                    </a:moveTo>
-                    <a:lnTo>
-                      <a:pt x="0" y="81225"/>
-                    </a:lnTo>
-                    <a:lnTo>
-                      <a:pt x="60325" y="81225"/>
-                    </a:lnTo>
-                  </a:path>
-                </a:pathLst>
-              </a:custGeom>
-              <a:noFill/>
-              <a:ln w="30162">
+        <p:sp>
+          <p:nvSpPr>
+            <p:cNvPr id="55" name="Best practice heading"/>
+            <p:cNvSpPr txBox="1"/>
+            <p:nvPr/>
+          </p:nvSpPr>
+          <p:spPr>
+            <a:xfrm>
+              <a:off x="7277100" y="2133600"/>
+              <a:ext cx="4076700" cy="409575"/>
+            </a:xfrm>
+            <a:prstGeom prst="rect">
+              <a:avLst/>
+            </a:prstGeom>
+            <a:noFill/>
+            <a:ln>
+              <a:noFill/>
+            </a:ln>
+          </p:spPr>
+          <p:txBody>
+            <a:bodyPr wrap="square" lIns="0" tIns="0" rIns="0" bIns="0" anchor="t" anchorCtr="0">
+              <a:spAutoFit/>
+            </a:bodyPr>
+            <a:lstStyle/>
+            <a:p>
+              <a:pPr algn="l"/>
+              <a:r>
+                <a:rPr lang="en" sz="2100" b="1">
+                  <a:solidFill>
+                    <a:schemeClr val="accent2"/>
+                  </a:solidFill>
+                  <a:latin typeface="+mn-lt"/>
+                  <a:ea typeface="+mn-ea"/>
+                  <a:cs typeface="+mn-cs"/>
+                </a:rPr>
+                <a:t>Best practice</a:t>
+              </a:r>
+            </a:p>
+          </p:txBody>
+        </p:sp>
+        <p:sp>
+          <p:nvSpPr>
+            <p:cNvPr id="56" name="Best practice list"/>
+            <p:cNvSpPr txBox="1"/>
+            <p:nvPr/>
+          </p:nvSpPr>
+          <p:spPr>
+            <a:xfrm>
+              <a:off x="7277100" y="2668447"/>
+              <a:ext cx="4076700" cy="525785"/>
+            </a:xfrm>
+            <a:prstGeom prst="rect">
+              <a:avLst/>
+            </a:prstGeom>
+            <a:noFill/>
+            <a:ln>
+              <a:noFill/>
+            </a:ln>
+          </p:spPr>
+          <p:txBody>
+            <a:bodyPr wrap="square" lIns="0" tIns="0" rIns="0" bIns="0" anchor="t" anchorCtr="0">
+              <a:spAutoFit/>
+            </a:bodyPr>
+            <a:lstStyle/>
+            <a:p>
+              <a:pPr marL="285750" indent="-285750">
+                <a:buClr>
+                  <a:schemeClr val="accent3"/>
+                </a:buClr>
+                <a:buSzPct val="100000"/>
+                <a:buFont typeface="Wingdings" pitchFamily="2" charset="2"/>
+                <a:buChar char="ü"/>
+              </a:pPr>
+              <a:r>
+                <a:rPr lang="en" sz="1500">
+                  <a:solidFill>
+                    <a:schemeClr val="accent1"/>
+                  </a:solidFill>
+                  <a:ea typeface="+mn-lt"/>
+                  <a:cs typeface="+mn-lt"/>
+                </a:rPr>
+                <a:t>Start with the simplest that fits</a:t>
+              </a:r>
+              <a:endParaRPr lang="en-US">
                 <a:solidFill>
-                  <a:schemeClr val="accent2"/>
+                  <a:schemeClr val="accent1"/>
                 </a:solidFill>
-              </a:ln>
-            </p:spPr>
-            <p:txBody>
-              <a:bodyPr/>
-              <a:lstStyle/>
-              <a:p>
-                <a:endParaRPr lang="en-150"/>
-              </a:p>
-            </p:txBody>
-          </p:sp>
-          <p:sp>
-            <p:nvSpPr>
-              <p:cNvPr id="19" name="Freeform 19"/>
-              <p:cNvSpPr/>
-              <p:nvPr/>
-            </p:nvSpPr>
-            <p:spPr>
-              <a:xfrm>
-                <a:off x="7985125" y="2615406"/>
-                <a:ext cx="241299" cy="111387"/>
-              </a:xfrm>
-              <a:custGeom>
-                <a:avLst/>
-                <a:gdLst/>
-                <a:ahLst/>
-                <a:cxnLst/>
-                <a:rect l="l" t="t" r="r" b="b"/>
-                <a:pathLst>
-                  <a:path w="241299" h="111387">
-                    <a:moveTo>
-                      <a:pt x="0" y="0"/>
-                    </a:moveTo>
-                    <a:cubicBezTo>
-                      <a:pt x="7582" y="54556"/>
-                      <a:pt x="50735" y="97290"/>
-                      <a:pt x="105362" y="104339"/>
-                    </a:cubicBezTo>
-                    <a:cubicBezTo>
-                      <a:pt x="159990" y="111387"/>
-                      <a:pt x="212577" y="81007"/>
-                      <a:pt x="233759" y="30162"/>
-                    </a:cubicBezTo>
-                    <a:moveTo>
-                      <a:pt x="241299" y="90487"/>
-                    </a:moveTo>
-                    <a:lnTo>
-                      <a:pt x="241299" y="30162"/>
-                    </a:lnTo>
-                    <a:lnTo>
-                      <a:pt x="180975" y="30162"/>
-                    </a:lnTo>
-                  </a:path>
-                </a:pathLst>
-              </a:custGeom>
-              <a:noFill/>
-              <a:ln w="30162">
+              </a:endParaRPr>
+            </a:p>
+            <a:p>
+              <a:pPr marL="285750" indent="-285750">
+                <a:spcBef>
+                  <a:spcPts val="500"/>
+                </a:spcBef>
+                <a:buClr>
+                  <a:schemeClr val="accent3"/>
+                </a:buClr>
+                <a:buSzPct val="100000"/>
+                <a:buFont typeface="Wingdings" pitchFamily="2" charset="2"/>
+                <a:buChar char="ü"/>
+              </a:pPr>
+              <a:r>
+                <a:rPr lang="en" sz="1500">
+                  <a:solidFill>
+                    <a:schemeClr val="accent1"/>
+                  </a:solidFill>
+                  <a:ea typeface="+mn-lt"/>
+                  <a:cs typeface="+mn-lt"/>
+                </a:rPr>
+                <a:t>Share one connection per app</a:t>
+              </a:r>
+              <a:endParaRPr lang="en">
                 <a:solidFill>
-                  <a:schemeClr val="accent2"/>
+                  <a:schemeClr val="accent1"/>
                 </a:solidFill>
-              </a:ln>
-            </p:spPr>
-            <p:txBody>
-              <a:bodyPr/>
-              <a:lstStyle/>
-              <a:p>
-                <a:endParaRPr lang="en-150"/>
-              </a:p>
-            </p:txBody>
-          </p:sp>
-        </p:grpSp>
-        <p:sp>
-          <p:nvSpPr>
-            <p:cNvPr id="21" name="TextBox 21"/>
-            <p:cNvSpPr txBox="1"/>
-            <p:nvPr/>
-          </p:nvSpPr>
-          <p:spPr>
-            <a:xfrm>
-              <a:off x="8485632" y="2432050"/>
-              <a:ext cx="2356176" cy="410718"/>
-            </a:xfrm>
-            <a:prstGeom prst="rect">
-              <a:avLst/>
-            </a:prstGeom>
-            <a:noFill/>
-            <a:ln>
-              <a:noFill/>
-            </a:ln>
-          </p:spPr>
-          <p:txBody>
-            <a:bodyPr wrap="none" lIns="0" tIns="0" rIns="0" bIns="0" anchor="t" anchorCtr="0">
+              </a:endParaRPr>
+            </a:p>
+          </p:txBody>
+        </p:sp>
+        <p:sp>
+          <p:nvSpPr>
+            <p:cNvPr id="57" name="Avoid card"/>
+            <p:cNvSpPr/>
+            <p:nvPr/>
+          </p:nvSpPr>
+          <p:spPr>
+            <a:xfrm>
+              <a:off x="7048500" y="3657600"/>
+              <a:ext cx="4533900" cy="1495425"/>
+            </a:xfrm>
+            <a:prstGeom prst="roundRect">
+              <a:avLst>
+                <a:gd name="adj" fmla="val 7643"/>
+              </a:avLst>
+            </a:prstGeom>
+            <a:solidFill>
+              <a:srgbClr val="FBF1E3"/>
+            </a:solidFill>
+            <a:ln>
+              <a:noFill/>
+            </a:ln>
+          </p:spPr>
+          <p:txBody>
+            <a:bodyPr/>
+            <a:lstStyle/>
+            <a:p>
+              <a:endParaRPr lang="en-150"/>
+            </a:p>
+          </p:txBody>
+        </p:sp>
+        <p:sp>
+          <p:nvSpPr>
+            <p:cNvPr id="58" name="Avoid heading"/>
+            <p:cNvSpPr txBox="1"/>
+            <p:nvPr/>
+          </p:nvSpPr>
+          <p:spPr>
+            <a:xfrm>
+              <a:off x="7277100" y="3752850"/>
+              <a:ext cx="4076700" cy="409575"/>
+            </a:xfrm>
+            <a:prstGeom prst="rect">
+              <a:avLst/>
+            </a:prstGeom>
+            <a:noFill/>
+            <a:ln>
+              <a:noFill/>
+            </a:ln>
+          </p:spPr>
+          <p:txBody>
+            <a:bodyPr wrap="square" lIns="0" tIns="0" rIns="0" bIns="0" anchor="t" anchorCtr="0">
               <a:spAutoFit/>
             </a:bodyPr>
             <a:lstStyle/>
             <a:p>
               <a:pPr algn="l"/>
               <a:r>
-                <a:rPr lang="en" sz="2100" dirty="0">
+                <a:rPr lang="en" sz="2100" b="1">
+                  <a:solidFill>
+                    <a:srgbClr val="B36A13"/>
+                  </a:solidFill>
+                  <a:latin typeface="+mn-lt"/>
+                  <a:ea typeface="+mn-ea"/>
+                  <a:cs typeface="+mn-cs"/>
+                </a:rPr>
+                <a:t>Avoid</a:t>
+              </a:r>
+            </a:p>
+          </p:txBody>
+        </p:sp>
+        <p:sp>
+          <p:nvSpPr>
+            <p:cNvPr id="59" name="Avoid list"/>
+            <p:cNvSpPr txBox="1"/>
+            <p:nvPr/>
+          </p:nvSpPr>
+          <p:spPr>
+            <a:xfrm>
+              <a:off x="7277100" y="4279637"/>
+              <a:ext cx="4076700" cy="525785"/>
+            </a:xfrm>
+            <a:prstGeom prst="rect">
+              <a:avLst/>
+            </a:prstGeom>
+            <a:noFill/>
+            <a:ln>
+              <a:noFill/>
+            </a:ln>
+          </p:spPr>
+          <p:txBody>
+            <a:bodyPr wrap="square" lIns="0" tIns="0" rIns="0" bIns="0" anchor="t" anchorCtr="0">
+              <a:spAutoFit/>
+            </a:bodyPr>
+            <a:lstStyle/>
+            <a:p>
+              <a:pPr marL="285750" indent="-285750">
+                <a:buClr>
+                  <a:srgbClr val="B36A13"/>
+                </a:buClr>
+                <a:buSzPct val="100000"/>
+                <a:buFont typeface="Wingdings" pitchFamily="2" charset="2"/>
+                <a:buChar char="û"/>
+              </a:pPr>
+              <a:r>
+                <a:rPr lang="en" sz="1500">
                   <a:solidFill>
                     <a:schemeClr val="accent1"/>
                   </a:solidFill>
-                  <a:latin typeface="+mn-lt"/>
-                  <a:ea typeface="+mn-ea"/>
-                  <a:cs typeface="+mn-cs"/>
-                </a:rPr>
-                <a:t>Reuse connections</a:t>
-              </a:r>
-            </a:p>
-          </p:txBody>
-        </p:sp>
-        <p:sp>
-          <p:nvSpPr>
-            <p:cNvPr id="22" name="TextBox 22"/>
-            <p:cNvSpPr txBox="1"/>
-            <p:nvPr/>
-          </p:nvSpPr>
-          <p:spPr>
-            <a:xfrm>
-              <a:off x="7917180" y="2943225"/>
-              <a:ext cx="1808922" cy="293370"/>
-            </a:xfrm>
-            <a:prstGeom prst="rect">
-              <a:avLst/>
-            </a:prstGeom>
-            <a:noFill/>
-            <a:ln>
-              <a:noFill/>
-            </a:ln>
-          </p:spPr>
-          <p:txBody>
-            <a:bodyPr wrap="none" lIns="0" tIns="0" rIns="0" bIns="0" anchor="t" anchorCtr="0">
-              <a:spAutoFit/>
-            </a:bodyPr>
-            <a:lstStyle/>
-            <a:p>
-              <a:pPr algn="l"/>
-              <a:r>
-                <a:rPr lang="en" sz="1500" dirty="0">
-                  <a:solidFill>
-                    <a:schemeClr val="accent5"/>
-                  </a:solidFill>
-                  <a:latin typeface="+mn-lt"/>
-                  <a:ea typeface="+mn-ea"/>
-                  <a:cs typeface="+mn-cs"/>
-                </a:rPr>
-                <a:t>Not one per widget.</a:t>
-              </a:r>
-            </a:p>
-          </p:txBody>
-        </p:sp>
-        <p:grpSp>
-          <p:nvGrpSpPr>
-            <p:cNvPr id="25" name="Group 25"/>
-            <p:cNvGrpSpPr/>
-            <p:nvPr/>
-          </p:nvGrpSpPr>
-          <p:grpSpPr>
-            <a:xfrm>
-              <a:off x="7949691" y="3588544"/>
-              <a:ext cx="294509" cy="271462"/>
-              <a:chOff x="7949691" y="3588544"/>
-              <a:chExt cx="294509" cy="271462"/>
-            </a:xfrm>
-          </p:grpSpPr>
-          <p:sp>
-            <p:nvSpPr>
-              <p:cNvPr id="23" name="Freeform 23"/>
-              <p:cNvSpPr/>
-              <p:nvPr/>
-            </p:nvSpPr>
-            <p:spPr>
-              <a:xfrm>
-                <a:off x="7949691" y="3588544"/>
-                <a:ext cx="294509" cy="269139"/>
-              </a:xfrm>
-              <a:custGeom>
-                <a:avLst/>
-                <a:gdLst/>
-                <a:ahLst/>
-                <a:cxnLst/>
-                <a:rect l="l" t="t" r="r" b="b"/>
-                <a:pathLst>
-                  <a:path w="294509" h="269139">
-                    <a:moveTo>
-                      <a:pt x="147940" y="269139"/>
-                    </a:moveTo>
-                    <a:cubicBezTo>
-                      <a:pt x="53463" y="239854"/>
-                      <a:pt x="0" y="140141"/>
-                      <a:pt x="27893" y="45244"/>
-                    </a:cubicBezTo>
-                    <a:cubicBezTo>
-                      <a:pt x="74879" y="47394"/>
-                      <a:pt x="120857" y="31166"/>
-                      <a:pt x="156084" y="0"/>
-                    </a:cubicBezTo>
-                    <a:cubicBezTo>
-                      <a:pt x="191311" y="31166"/>
-                      <a:pt x="237288" y="47394"/>
-                      <a:pt x="284274" y="45244"/>
-                    </a:cubicBezTo>
-                    <a:cubicBezTo>
-                      <a:pt x="294509" y="80068"/>
-                      <a:pt x="294037" y="117165"/>
-                      <a:pt x="282917" y="151717"/>
-                    </a:cubicBezTo>
-                  </a:path>
-                </a:pathLst>
-              </a:custGeom>
-              <a:noFill/>
-              <a:ln w="30162">
+                  <a:ea typeface="+mn-lt"/>
+                  <a:cs typeface="+mn-lt"/>
+                </a:rPr>
+                <a:t>Assuming the connection stays alive</a:t>
+              </a:r>
+              <a:endParaRPr lang="en-US">
                 <a:solidFill>
-                  <a:schemeClr val="accent2"/>
+                  <a:schemeClr val="accent1"/>
                 </a:solidFill>
-              </a:ln>
-            </p:spPr>
-            <p:txBody>
-              <a:bodyPr/>
-              <a:lstStyle/>
-              <a:p>
-                <a:endParaRPr lang="en-150"/>
-              </a:p>
-            </p:txBody>
-          </p:sp>
-          <p:sp>
-            <p:nvSpPr>
-              <p:cNvPr id="24" name="Freeform 24"/>
-              <p:cNvSpPr/>
-              <p:nvPr/>
-            </p:nvSpPr>
-            <p:spPr>
-              <a:xfrm>
-                <a:off x="8151018" y="3799681"/>
-                <a:ext cx="90487" cy="60325"/>
-              </a:xfrm>
-              <a:custGeom>
-                <a:avLst/>
-                <a:gdLst/>
-                <a:ahLst/>
-                <a:cxnLst/>
-                <a:rect l="l" t="t" r="r" b="b"/>
-                <a:pathLst>
-                  <a:path w="90487" h="60325">
-                    <a:moveTo>
-                      <a:pt x="0" y="30162"/>
-                    </a:moveTo>
-                    <a:lnTo>
-                      <a:pt x="30162" y="60325"/>
-                    </a:lnTo>
-                    <a:lnTo>
-                      <a:pt x="90487" y="0"/>
-                    </a:lnTo>
-                  </a:path>
-                </a:pathLst>
-              </a:custGeom>
-              <a:noFill/>
-              <a:ln w="30162">
-                <a:solidFill>
-                  <a:schemeClr val="accent2"/>
-                </a:solidFill>
-              </a:ln>
-            </p:spPr>
-            <p:txBody>
-              <a:bodyPr/>
-              <a:lstStyle/>
-              <a:p>
-                <a:endParaRPr lang="en-150"/>
-              </a:p>
-            </p:txBody>
-          </p:sp>
-        </p:grpSp>
-        <p:sp>
-          <p:nvSpPr>
-            <p:cNvPr id="26" name="TextBox 26"/>
-            <p:cNvSpPr txBox="1"/>
-            <p:nvPr/>
-          </p:nvSpPr>
-          <p:spPr>
-            <a:xfrm>
-              <a:off x="8485632" y="3556000"/>
-              <a:ext cx="2196906" cy="410718"/>
-            </a:xfrm>
-            <a:prstGeom prst="rect">
-              <a:avLst/>
-            </a:prstGeom>
-            <a:noFill/>
-            <a:ln>
-              <a:noFill/>
-            </a:ln>
-          </p:spPr>
-          <p:txBody>
-            <a:bodyPr wrap="none" lIns="0" tIns="0" rIns="0" bIns="0" anchor="t" anchorCtr="0">
-              <a:spAutoFit/>
-            </a:bodyPr>
-            <a:lstStyle/>
-            <a:p>
-              <a:pPr algn="l"/>
-              <a:r>
-                <a:rPr lang="en" sz="2100" dirty="0">
+              </a:endParaRPr>
+            </a:p>
+            <a:p>
+              <a:pPr marL="285750" indent="-285750">
+                <a:spcBef>
+                  <a:spcPts val="500"/>
+                </a:spcBef>
+                <a:buClr>
+                  <a:srgbClr val="B36A13"/>
+                </a:buClr>
+                <a:buSzPct val="100000"/>
+                <a:buFont typeface="Wingdings" pitchFamily="2" charset="2"/>
+                <a:buChar char="û"/>
+              </a:pPr>
+              <a:r>
+                <a:rPr lang="en" sz="1500">
                   <a:solidFill>
                     <a:schemeClr val="accent1"/>
                   </a:solidFill>
-                  <a:latin typeface="+mn-lt"/>
-                  <a:ea typeface="+mn-ea"/>
-                  <a:cs typeface="+mn-cs"/>
-                </a:rPr>
-                <a:t>Authorize actions</a:t>
-              </a:r>
-            </a:p>
-          </p:txBody>
-        </p:sp>
-        <p:sp>
-          <p:nvSpPr>
-            <p:cNvPr id="27" name="TextBox 27"/>
-            <p:cNvSpPr txBox="1"/>
-            <p:nvPr/>
-          </p:nvSpPr>
-          <p:spPr>
-            <a:xfrm>
-              <a:off x="7917180" y="4067175"/>
-              <a:ext cx="3053400" cy="293370"/>
-            </a:xfrm>
-            <a:prstGeom prst="rect">
-              <a:avLst/>
-            </a:prstGeom>
-            <a:noFill/>
-            <a:ln>
-              <a:noFill/>
-            </a:ln>
-          </p:spPr>
-          <p:txBody>
-            <a:bodyPr wrap="none" lIns="0" tIns="0" rIns="0" bIns="0" anchor="t" anchorCtr="0">
-              <a:spAutoFit/>
-            </a:bodyPr>
-            <a:lstStyle/>
-            <a:p>
-              <a:pPr algn="l"/>
-              <a:r>
-                <a:rPr lang="en" sz="1500" dirty="0">
-                  <a:solidFill>
-                    <a:schemeClr val="accent5"/>
-                  </a:solidFill>
-                  <a:latin typeface="+mn-lt"/>
-                  <a:ea typeface="+mn-ea"/>
-                  <a:cs typeface="+mn-cs"/>
-                </a:rPr>
-                <a:t>Never trust client-supplied rooms.</a:t>
-              </a:r>
+                  <a:ea typeface="+mn-lt"/>
+                  <a:cs typeface="+mn-lt"/>
+                </a:rPr>
+                <a:t>Polling every second to feel real-time</a:t>
+              </a:r>
+              <a:endParaRPr lang="en"/>
             </a:p>
           </p:txBody>
         </p:sp>
       </p:grpSp>
       <p:grpSp>
         <p:nvGrpSpPr>
-          <p:cNvPr id="30" name="tradeoff"/>
+          <p:cNvPr id="62" name="tradeoff"/>
           <p:cNvGrpSpPr/>
           <p:nvPr/>
         </p:nvGrpSpPr>
         <p:grpSpPr>
           <a:xfrm>
-            <a:off x="597408" y="5403850"/>
-            <a:ext cx="6640136" cy="469392"/>
-            <a:chOff x="597408" y="5403850"/>
-            <a:chExt cx="6640136" cy="469392"/>
+            <a:off x="609600" y="5486400"/>
+            <a:ext cx="6667500" cy="466725"/>
+            <a:chOff x="609600" y="5486400"/>
+            <a:chExt cx="6667500" cy="466725"/>
           </a:xfrm>
         </p:grpSpPr>
         <p:sp>
           <p:nvSpPr>
-            <p:cNvPr id="29" name="TextBox 29"/>
-            <p:cNvSpPr txBox="1"/>
-            <p:nvPr/>
-          </p:nvSpPr>
-          <p:spPr>
-            <a:xfrm>
-              <a:off x="597408" y="5403850"/>
-              <a:ext cx="6640136" cy="469392"/>
-            </a:xfrm>
-            <a:prstGeom prst="rect">
-              <a:avLst/>
-            </a:prstGeom>
-            <a:noFill/>
-            <a:ln>
-              <a:noFill/>
-            </a:ln>
-          </p:spPr>
-          <p:txBody>
-            <a:bodyPr wrap="none" lIns="0" tIns="0" rIns="0" bIns="0" anchor="t" anchorCtr="0">
+            <p:cNvPr id="61" name="Tagline"/>
+            <p:cNvSpPr txBox="1"/>
+            <p:nvPr/>
+          </p:nvSpPr>
+          <p:spPr>
+            <a:xfrm>
+              <a:off x="609600" y="5486400"/>
+              <a:ext cx="6667500" cy="466725"/>
+            </a:xfrm>
+            <a:prstGeom prst="rect">
+              <a:avLst/>
+            </a:prstGeom>
+            <a:noFill/>
+            <a:ln>
+              <a:noFill/>
+            </a:ln>
+          </p:spPr>
+          <p:txBody>
+            <a:bodyPr wrap="square" lIns="0" tIns="0" rIns="0" bIns="0" anchor="t" anchorCtr="0">
               <a:spAutoFit/>
             </a:bodyPr>
             <a:lstStyle/>
             <a:p>
               <a:pPr algn="l"/>
               <a:r>
-                <a:rPr lang="en" sz="2400" dirty="0">
+                <a:rPr lang="en" sz="2400">
                   <a:solidFill>
                     <a:schemeClr val="accent1"/>
                   </a:solidFill>
@@ -3609,7 +3791,7 @@
                 <a:t>Less polling. </a:t>
               </a:r>
               <a:r>
-                <a:rPr lang="en" sz="2400" b="1" dirty="0">
+                <a:rPr lang="en" sz="2400" b="1">
                   <a:solidFill>
                     <a:schemeClr val="accent2"/>
                   </a:solidFill>
@@ -3664,7 +3846,7 @@
             <a:p>
               <a:pPr algn="l"/>
               <a:r>
-                <a:rPr lang="en" sz="1050" dirty="0">
+                <a:rPr lang="en" sz="1050">
                   <a:solidFill>
                     <a:schemeClr val="accent5"/>
                   </a:solidFill>
@@ -3704,7 +3886,7 @@
             <a:p>
               <a:pPr algn="r"/>
               <a:r>
-                <a:rPr lang="en" sz="1050" dirty="0">
+                <a:rPr lang="en" sz="1050">
                   <a:solidFill>
                     <a:schemeClr val="accent5"/>
                   </a:solidFill>
@@ -3772,9 +3954,9 @@
         <p:grpSpPr>
           <a:xfrm>
             <a:off x="552450" y="1028700"/>
-            <a:ext cx="4910448" cy="2079625"/>
+            <a:ext cx="4207883" cy="1862872"/>
             <a:chOff x="552450" y="1028700"/>
-            <a:chExt cx="4910448" cy="2079625"/>
+            <a:chExt cx="4207883" cy="1862872"/>
           </a:xfrm>
         </p:grpSpPr>
         <p:sp>
@@ -3833,7 +4015,7 @@
             <a:p>
               <a:pPr algn="l"/>
               <a:r>
-                <a:rPr lang="en" sz="2400" b="1" dirty="0">
+                <a:rPr lang="en" sz="2400" b="1">
                   <a:solidFill>
                     <a:schemeClr val="accent2"/>
                   </a:solidFill>
@@ -3855,25 +4037,24 @@
           <p:spPr>
             <a:xfrm>
               <a:off x="552450" y="2060575"/>
-              <a:ext cx="4910448" cy="1047750"/>
-            </a:xfrm>
-            <a:prstGeom prst="rect">
-              <a:avLst/>
-            </a:prstGeom>
-            <a:noFill/>
-            <a:ln>
-              <a:noFill/>
-            </a:ln>
-          </p:spPr>
-          <p:txBody>
-            <a:bodyPr wrap="none" lIns="0" tIns="0" rIns="0" bIns="0" anchor="t" anchorCtr="0">
-              <a:spAutoFit/>
-            </a:bodyPr>
-            <a:lstStyle/>
-            <a:p>
-              <a:pPr algn="l"/>
-              <a:r>
-                <a:rPr lang="en" sz="5400" b="1" dirty="0">
+              <a:ext cx="4207883" cy="830997"/>
+            </a:xfrm>
+            <a:prstGeom prst="rect">
+              <a:avLst/>
+            </a:prstGeom>
+            <a:noFill/>
+            <a:ln>
+              <a:noFill/>
+            </a:ln>
+          </p:spPr>
+          <p:txBody>
+            <a:bodyPr wrap="none" lIns="0" tIns="0" rIns="0" bIns="0" anchor="t" anchorCtr="0">
+              <a:spAutoFit/>
+            </a:bodyPr>
+            <a:lstStyle/>
+            <a:p>
+              <a:r>
+                <a:rPr lang="en" sz="5400" b="1">
                   <a:solidFill>
                     <a:schemeClr val="accent1"/>
                   </a:solidFill>
@@ -3881,7 +4062,26 @@
                   <a:ea typeface="+mn-ea"/>
                   <a:cs typeface="+mn-cs"/>
                 </a:rPr>
-                <a:t>Demo &amp; Q&amp;A</a:t>
+                <a:t>Demo </a:t>
+              </a:r>
+              <a:r>
+                <a:rPr lang="en" sz="5400" b="1">
+                  <a:solidFill>
+                    <a:schemeClr val="accent1"/>
+                  </a:solidFill>
+                </a:rPr>
+                <a:t>- </a:t>
+              </a:r>
+              <a:r>
+                <a:rPr lang="en" sz="5400" b="1">
+                  <a:solidFill>
+                    <a:schemeClr val="accent1"/>
+                  </a:solidFill>
+                  <a:latin typeface="+mn-lt"/>
+                  <a:ea typeface="+mn-ea"/>
+                  <a:cs typeface="+mn-cs"/>
+                </a:rPr>
+                <a:t>Q&amp;A</a:t>
               </a:r>
             </a:p>
           </p:txBody>
@@ -3928,7 +4128,7 @@
             <a:p>
               <a:pPr algn="l"/>
               <a:r>
-                <a:rPr lang="en" sz="2400" dirty="0">
+                <a:rPr lang="en" sz="2400">
                   <a:solidFill>
                     <a:schemeClr val="accent5"/>
                   </a:solidFill>
@@ -4129,7 +4329,7 @@
             <a:p>
               <a:pPr algn="l"/>
               <a:r>
-                <a:rPr lang="en" sz="2100" dirty="0">
+                <a:rPr lang="en" sz="2100">
                   <a:solidFill>
                     <a:schemeClr val="accent1"/>
                   </a:solidFill>
@@ -4169,7 +4369,7 @@
             <a:p>
               <a:pPr algn="l"/>
               <a:r>
-                <a:rPr lang="en" sz="2100" dirty="0">
+                <a:rPr lang="en" sz="2100">
                   <a:solidFill>
                     <a:schemeClr val="accent1"/>
                   </a:solidFill>
@@ -4209,7 +4409,7 @@
             <a:p>
               <a:pPr algn="l"/>
               <a:r>
-                <a:rPr lang="en" sz="2100" dirty="0">
+                <a:rPr lang="en" sz="2100">
                   <a:solidFill>
                     <a:schemeClr val="accent1"/>
                   </a:solidFill>
@@ -4249,7 +4449,7 @@
             <a:p>
               <a:pPr algn="l"/>
               <a:r>
-                <a:rPr lang="en" sz="2100" dirty="0">
+                <a:rPr lang="en" sz="2100">
                   <a:solidFill>
                     <a:schemeClr val="accent1"/>
                   </a:solidFill>
@@ -4304,7 +4504,7 @@
             <a:p>
               <a:pPr algn="l"/>
               <a:r>
-                <a:rPr lang="en" sz="1050" dirty="0">
+                <a:rPr lang="en" sz="1050">
                   <a:solidFill>
                     <a:schemeClr val="accent5"/>
                   </a:solidFill>
@@ -4344,7 +4544,7 @@
             <a:p>
               <a:pPr algn="r"/>
               <a:r>
-                <a:rPr lang="en" sz="1050" dirty="0">
+                <a:rPr lang="en" sz="1050">
                   <a:solidFill>
                     <a:schemeClr val="accent5"/>
                   </a:solidFill>
@@ -4444,7 +4644,7 @@
             <a:p>
               <a:pPr algn="l"/>
               <a:r>
-                <a:rPr lang="en" sz="2400" b="1" dirty="0">
+                <a:rPr lang="en" sz="2400" b="1">
                   <a:solidFill>
                     <a:schemeClr val="accent2"/>
                   </a:solidFill>
@@ -4484,7 +4684,7 @@
             <a:p>
               <a:pPr algn="l"/>
               <a:r>
-                <a:rPr lang="en" sz="3600" b="1" dirty="0">
+                <a:rPr lang="en" sz="3600" b="1">
                   <a:solidFill>
                     <a:schemeClr val="accent1"/>
                   </a:solidFill>
@@ -4539,7 +4739,7 @@
             <a:p>
               <a:pPr algn="l"/>
               <a:r>
-                <a:rPr lang="en" sz="2400" dirty="0">
+                <a:rPr lang="en" sz="2400">
                   <a:solidFill>
                     <a:schemeClr val="accent2"/>
                   </a:solidFill>
@@ -4579,7 +4779,7 @@
             <a:p>
               <a:pPr algn="l"/>
               <a:r>
-                <a:rPr lang="en" sz="2400" dirty="0">
+                <a:rPr lang="en" sz="2400">
                   <a:solidFill>
                     <a:schemeClr val="accent1"/>
                   </a:solidFill>
@@ -4677,7 +4877,7 @@
             <a:p>
               <a:pPr algn="l"/>
               <a:r>
-                <a:rPr lang="en" sz="2400" dirty="0">
+                <a:rPr lang="en" sz="2400">
                   <a:solidFill>
                     <a:schemeClr val="accent2"/>
                   </a:solidFill>
@@ -4717,7 +4917,7 @@
             <a:p>
               <a:pPr algn="l"/>
               <a:r>
-                <a:rPr lang="en" sz="2400" dirty="0">
+                <a:rPr lang="en" sz="2400">
                   <a:solidFill>
                     <a:schemeClr val="accent1"/>
                   </a:solidFill>
@@ -4815,7 +5015,7 @@
             <a:p>
               <a:pPr algn="l"/>
               <a:r>
-                <a:rPr lang="en" sz="2400" dirty="0">
+                <a:rPr lang="en" sz="2400">
                   <a:solidFill>
                     <a:schemeClr val="accent2"/>
                   </a:solidFill>
@@ -4855,7 +5055,7 @@
             <a:p>
               <a:pPr algn="l"/>
               <a:r>
-                <a:rPr lang="en" sz="2400" dirty="0">
+                <a:rPr lang="en" sz="2400">
                   <a:solidFill>
                     <a:schemeClr val="accent1"/>
                   </a:solidFill>
@@ -4921,9 +5121,9 @@
         <p:grpSpPr>
           <a:xfrm>
             <a:off x="597408" y="5118100"/>
-            <a:ext cx="2976260" cy="469392"/>
+            <a:ext cx="2679586" cy="469392"/>
             <a:chOff x="597408" y="5118100"/>
-            <a:chExt cx="2976260" cy="469392"/>
+            <a:chExt cx="2679586" cy="469392"/>
           </a:xfrm>
         </p:grpSpPr>
         <p:sp>
@@ -4953,7 +5153,7 @@
             <a:p>
               <a:pPr algn="l"/>
               <a:r>
-                <a:rPr lang="en" sz="2400" dirty="0">
+                <a:rPr lang="en" sz="2400">
                   <a:solidFill>
                     <a:schemeClr val="accent2"/>
                   </a:solidFill>
@@ -4975,25 +5175,24 @@
           <p:spPr>
             <a:xfrm>
               <a:off x="1483233" y="5118100"/>
-              <a:ext cx="2090435" cy="469392"/>
-            </a:xfrm>
-            <a:prstGeom prst="rect">
-              <a:avLst/>
-            </a:prstGeom>
-            <a:noFill/>
-            <a:ln>
-              <a:noFill/>
-            </a:ln>
-          </p:spPr>
-          <p:txBody>
-            <a:bodyPr wrap="none" lIns="0" tIns="0" rIns="0" bIns="0" anchor="t" anchorCtr="0">
-              <a:spAutoFit/>
-            </a:bodyPr>
-            <a:lstStyle/>
-            <a:p>
-              <a:pPr algn="l"/>
-              <a:r>
-                <a:rPr lang="en" sz="2400" dirty="0">
+              <a:ext cx="1793761" cy="369332"/>
+            </a:xfrm>
+            <a:prstGeom prst="rect">
+              <a:avLst/>
+            </a:prstGeom>
+            <a:noFill/>
+            <a:ln>
+              <a:noFill/>
+            </a:ln>
+          </p:spPr>
+          <p:txBody>
+            <a:bodyPr wrap="none" lIns="0" tIns="0" rIns="0" bIns="0" anchor="t" anchorCtr="0">
+              <a:spAutoFit/>
+            </a:bodyPr>
+            <a:lstStyle/>
+            <a:p>
+              <a:r>
+                <a:rPr lang="en" sz="2400">
                   <a:solidFill>
                     <a:schemeClr val="accent1"/>
                   </a:solidFill>
@@ -5001,7 +5200,26 @@
                   <a:ea typeface="+mn-ea"/>
                   <a:cs typeface="+mn-cs"/>
                 </a:rPr>
-                <a:t>Demo &amp; Q&amp;A</a:t>
+                <a:t>Demo </a:t>
+              </a:r>
+              <a:r>
+                <a:rPr lang="en" sz="2400">
+                  <a:solidFill>
+                    <a:schemeClr val="accent1"/>
+                  </a:solidFill>
+                </a:rPr>
+                <a:t>- </a:t>
+              </a:r>
+              <a:r>
+                <a:rPr lang="en" sz="2400">
+                  <a:solidFill>
+                    <a:schemeClr val="accent1"/>
+                  </a:solidFill>
+                  <a:latin typeface="+mn-lt"/>
+                  <a:ea typeface="+mn-ea"/>
+                  <a:cs typeface="+mn-cs"/>
+                </a:rPr>
+                <a:t>Q&amp;A</a:t>
               </a:r>
             </a:p>
           </p:txBody>
@@ -5048,7 +5266,7 @@
             <a:p>
               <a:pPr algn="l"/>
               <a:r>
-                <a:rPr lang="en" sz="1050" dirty="0">
+                <a:rPr lang="en" sz="1050">
                   <a:solidFill>
                     <a:schemeClr val="accent5"/>
                   </a:solidFill>
@@ -5088,7 +5306,7 @@
             <a:p>
               <a:pPr algn="r"/>
               <a:r>
-                <a:rPr lang="en" sz="1050" dirty="0">
+                <a:rPr lang="en" sz="1050">
                   <a:solidFill>
                     <a:schemeClr val="accent5"/>
                   </a:solidFill>
@@ -5188,7 +5406,7 @@
             <a:p>
               <a:pPr algn="l"/>
               <a:r>
-                <a:rPr lang="en" sz="2400" b="1" dirty="0">
+                <a:rPr lang="en" sz="2400" b="1">
                   <a:solidFill>
                     <a:schemeClr val="accent2"/>
                   </a:solidFill>
@@ -5228,7 +5446,7 @@
             <a:p>
               <a:pPr algn="l"/>
               <a:r>
-                <a:rPr lang="en" sz="3600" b="1" dirty="0">
+                <a:rPr lang="en" sz="3600" b="1">
                   <a:solidFill>
                     <a:schemeClr val="accent1"/>
                   </a:solidFill>
@@ -5316,7 +5534,7 @@
             <a:p>
               <a:pPr algn="l"/>
               <a:r>
-                <a:rPr lang="en" sz="1500" dirty="0">
+                <a:rPr lang="en" sz="1500">
                   <a:solidFill>
                     <a:schemeClr val="accent5"/>
                   </a:solidFill>
@@ -5496,7 +5714,7 @@
             <a:p>
               <a:pPr algn="l"/>
               <a:r>
-                <a:rPr lang="en" sz="2100" dirty="0">
+                <a:rPr lang="en" sz="2100">
                   <a:solidFill>
                     <a:schemeClr val="accent1"/>
                   </a:solidFill>
@@ -5842,7 +6060,7 @@
             <a:p>
               <a:pPr algn="ctr"/>
               <a:r>
-                <a:rPr lang="en" sz="1500" dirty="0">
+                <a:rPr lang="en" sz="1500">
                   <a:solidFill>
                     <a:srgbClr val="FFFFFF"/>
                   </a:solidFill>
@@ -5928,7 +6146,7 @@
             <a:p>
               <a:pPr algn="ctr"/>
               <a:r>
-                <a:rPr lang="en" sz="1500" dirty="0">
+                <a:rPr lang="en" sz="1500">
                   <a:solidFill>
                     <a:srgbClr val="B36A13"/>
                   </a:solidFill>
@@ -6001,7 +6219,7 @@
             <a:p>
               <a:pPr algn="l"/>
               <a:r>
-                <a:rPr lang="en" sz="1500" dirty="0">
+                <a:rPr lang="en" sz="1500">
                   <a:solidFill>
                     <a:schemeClr val="accent5"/>
                   </a:solidFill>
@@ -6234,7 +6452,7 @@
             <a:p>
               <a:pPr algn="ctr"/>
               <a:r>
-                <a:rPr lang="en" sz="1500" dirty="0">
+                <a:rPr lang="en" sz="1500">
                   <a:solidFill>
                     <a:schemeClr val="accent5"/>
                   </a:solidFill>
@@ -6274,7 +6492,7 @@
             <a:p>
               <a:pPr algn="ctr"/>
               <a:r>
-                <a:rPr lang="en" sz="1500" dirty="0">
+                <a:rPr lang="en" sz="1500">
                   <a:solidFill>
                     <a:srgbClr val="B36A13"/>
                   </a:solidFill>
@@ -6360,7 +6578,7 @@
             <a:p>
               <a:pPr algn="l"/>
               <a:r>
-                <a:rPr lang="en" sz="2400" b="1" dirty="0">
+                <a:rPr lang="en" sz="2400" b="1">
                   <a:solidFill>
                     <a:schemeClr val="accent2"/>
                   </a:solidFill>
@@ -6400,7 +6618,7 @@
             <a:p>
               <a:pPr algn="l"/>
               <a:r>
-                <a:rPr lang="en" sz="2100" dirty="0">
+                <a:rPr lang="en" sz="2100">
                   <a:solidFill>
                     <a:schemeClr val="accent1"/>
                   </a:solidFill>
@@ -6605,7 +6823,7 @@
             <a:p>
               <a:pPr algn="l"/>
               <a:r>
-                <a:rPr lang="en" sz="1050" dirty="0">
+                <a:rPr lang="en" sz="1050">
                   <a:solidFill>
                     <a:schemeClr val="accent5"/>
                   </a:solidFill>
@@ -6645,7 +6863,7 @@
             <a:p>
               <a:pPr algn="r"/>
               <a:r>
-                <a:rPr lang="en" sz="1050" dirty="0">
+                <a:rPr lang="en" sz="1050">
                   <a:solidFill>
                     <a:schemeClr val="accent5"/>
                   </a:solidFill>
@@ -6745,7 +6963,7 @@
             <a:p>
               <a:pPr algn="l"/>
               <a:r>
-                <a:rPr lang="en" sz="2400" b="1" dirty="0">
+                <a:rPr lang="en" sz="2400" b="1">
                   <a:solidFill>
                     <a:schemeClr val="accent2"/>
                   </a:solidFill>
@@ -6785,7 +7003,7 @@
             <a:p>
               <a:pPr algn="l"/>
               <a:r>
-                <a:rPr lang="en" sz="3600" b="1" dirty="0">
+                <a:rPr lang="en" sz="3600" b="1">
                   <a:solidFill>
                     <a:schemeClr val="accent1"/>
                   </a:solidFill>
@@ -6873,7 +7091,7 @@
             <a:p>
               <a:pPr algn="l"/>
               <a:r>
-                <a:rPr lang="en" sz="1500" dirty="0">
+                <a:rPr lang="en" sz="1500">
                   <a:solidFill>
                     <a:schemeClr val="accent5"/>
                   </a:solidFill>
@@ -6987,7 +7205,7 @@
             <a:p>
               <a:pPr algn="l"/>
               <a:r>
-                <a:rPr lang="en" sz="1500" dirty="0">
+                <a:rPr lang="en" sz="1500">
                   <a:solidFill>
                     <a:schemeClr val="accent1"/>
                   </a:solidFill>
@@ -7027,7 +7245,7 @@
             <a:p>
               <a:pPr algn="r"/>
               <a:r>
-                <a:rPr lang="en" sz="1500" dirty="0">
+                <a:rPr lang="en" sz="1500">
                   <a:solidFill>
                     <a:schemeClr val="accent3"/>
                   </a:solidFill>
@@ -7373,7 +7591,7 @@
             <a:p>
               <a:pPr algn="ctr"/>
               <a:r>
-                <a:rPr lang="en" sz="1500" dirty="0">
+                <a:rPr lang="en" sz="1500">
                   <a:solidFill>
                     <a:srgbClr val="FFFFFF"/>
                   </a:solidFill>
@@ -7492,7 +7710,7 @@
             <a:p>
               <a:pPr algn="l"/>
               <a:r>
-                <a:rPr lang="en" sz="1500" dirty="0">
+                <a:rPr lang="en" sz="1500">
                   <a:solidFill>
                     <a:schemeClr val="accent5"/>
                   </a:solidFill>
@@ -7662,7 +7880,7 @@
             <a:p>
               <a:pPr algn="ctr"/>
               <a:r>
-                <a:rPr lang="en" sz="2100" dirty="0">
+                <a:rPr lang="en" sz="2100">
                   <a:solidFill>
                     <a:srgbClr val="B36A13"/>
                   </a:solidFill>
@@ -7748,7 +7966,7 @@
             <a:p>
               <a:pPr algn="l"/>
               <a:r>
-                <a:rPr lang="en" sz="2400" b="1" dirty="0">
+                <a:rPr lang="en" sz="2400" b="1">
                   <a:solidFill>
                     <a:schemeClr val="accent2"/>
                   </a:solidFill>
@@ -7788,7 +8006,7 @@
             <a:p>
               <a:pPr algn="l"/>
               <a:r>
-                <a:rPr lang="en" sz="2100" dirty="0">
+                <a:rPr lang="en" sz="2100">
                   <a:solidFill>
                     <a:schemeClr val="accent1"/>
                   </a:solidFill>
@@ -7909,7 +8127,7 @@
             <a:p>
               <a:pPr algn="l"/>
               <a:r>
-                <a:rPr lang="en" sz="1050" dirty="0">
+                <a:rPr lang="en" sz="1050">
                   <a:solidFill>
                     <a:schemeClr val="accent5"/>
                   </a:solidFill>
@@ -7949,7 +8167,7 @@
             <a:p>
               <a:pPr algn="r"/>
               <a:r>
-                <a:rPr lang="en" sz="1050" dirty="0">
+                <a:rPr lang="en" sz="1050">
                   <a:solidFill>
                     <a:schemeClr val="accent5"/>
                   </a:solidFill>
@@ -8049,7 +8267,7 @@
             <a:p>
               <a:pPr algn="l"/>
               <a:r>
-                <a:rPr lang="en" sz="2400" b="1" dirty="0">
+                <a:rPr lang="en" sz="2400" b="1">
                   <a:solidFill>
                     <a:schemeClr val="accent2"/>
                   </a:solidFill>
@@ -8093,7 +8311,7 @@
                 </a:lnSpc>
               </a:pPr>
               <a:r>
-                <a:rPr lang="en" sz="3600" b="1" dirty="0">
+                <a:rPr lang="en" sz="3600" b="1">
                   <a:solidFill>
                     <a:schemeClr val="accent1"/>
                   </a:solidFill>
@@ -8104,7 +8322,7 @@
                 <a:t>From Repeated Requests</a:t>
               </a:r>
               <a:br>
-                <a:rPr lang="en" sz="3600" b="1" dirty="0">
+                <a:rPr lang="en" sz="3600" b="1">
                   <a:solidFill>
                     <a:schemeClr val="accent1"/>
                   </a:solidFill>
@@ -8114,7 +8332,7 @@
                 </a:rPr>
               </a:br>
               <a:r>
-                <a:rPr lang="en" sz="3600" b="1" dirty="0">
+                <a:rPr lang="en" sz="3600" b="1">
                   <a:solidFill>
                     <a:schemeClr val="accent1"/>
                   </a:solidFill>
@@ -8243,7 +8461,7 @@
             <a:p>
               <a:pPr algn="ctr"/>
               <a:r>
-                <a:rPr lang="en" sz="1500" dirty="0">
+                <a:rPr lang="en" sz="1500">
                   <a:solidFill>
                     <a:schemeClr val="accent2"/>
                   </a:solidFill>
@@ -8314,7 +8532,7 @@
             <a:p>
               <a:pPr algn="ctr"/>
               <a:r>
-                <a:rPr lang="en" sz="1500" dirty="0">
+                <a:rPr lang="en" sz="1500">
                   <a:solidFill>
                     <a:schemeClr val="accent2"/>
                   </a:solidFill>
@@ -8383,7 +8601,7 @@
             <a:p>
               <a:pPr algn="ctr"/>
               <a:r>
-                <a:rPr lang="en" sz="1500" dirty="0">
+                <a:rPr lang="en" sz="1500">
                   <a:solidFill>
                     <a:srgbClr val="FFFFFF"/>
                   </a:solidFill>
@@ -8452,7 +8670,7 @@
             <a:p>
               <a:pPr algn="ctr"/>
               <a:r>
-                <a:rPr lang="en" sz="1500" dirty="0">
+                <a:rPr lang="en" sz="1500">
                   <a:solidFill>
                     <a:srgbClr val="FFFFFF"/>
                   </a:solidFill>
@@ -8492,7 +8710,7 @@
             <a:p>
               <a:pPr algn="l"/>
               <a:r>
-                <a:rPr lang="en" sz="2400" b="1" dirty="0">
+                <a:rPr lang="en" sz="2400" b="1">
                   <a:solidFill>
                     <a:schemeClr val="accent1"/>
                   </a:solidFill>
@@ -8532,7 +8750,7 @@
             <a:p>
               <a:pPr algn="l"/>
               <a:r>
-                <a:rPr lang="en" sz="1500" dirty="0">
+                <a:rPr lang="en" sz="1500">
                   <a:solidFill>
                     <a:schemeClr val="accent5"/>
                   </a:solidFill>
@@ -8572,7 +8790,7 @@
             <a:p>
               <a:pPr algn="l"/>
               <a:r>
-                <a:rPr lang="en" sz="2400" b="1" dirty="0">
+                <a:rPr lang="en" sz="2400" b="1">
                   <a:solidFill>
                     <a:schemeClr val="accent1"/>
                   </a:solidFill>
@@ -8612,7 +8830,7 @@
             <a:p>
               <a:pPr algn="l"/>
               <a:r>
-                <a:rPr lang="en" sz="1500" dirty="0">
+                <a:rPr lang="en" sz="1500">
                   <a:solidFill>
                     <a:schemeClr val="accent5"/>
                   </a:solidFill>
@@ -8652,7 +8870,7 @@
             <a:p>
               <a:pPr algn="l"/>
               <a:r>
-                <a:rPr lang="en" sz="2400" b="1" dirty="0">
+                <a:rPr lang="en" sz="2400" b="1">
                   <a:solidFill>
                     <a:schemeClr val="accent1"/>
                   </a:solidFill>
@@ -8692,7 +8910,7 @@
             <a:p>
               <a:pPr algn="l"/>
               <a:r>
-                <a:rPr lang="en" sz="1500" dirty="0">
+                <a:rPr lang="en" sz="1500">
                   <a:solidFill>
                     <a:schemeClr val="accent5"/>
                   </a:solidFill>
@@ -8732,7 +8950,7 @@
             <a:p>
               <a:pPr algn="l"/>
               <a:r>
-                <a:rPr lang="en" sz="2400" b="1" dirty="0">
+                <a:rPr lang="en" sz="2400" b="1">
                   <a:solidFill>
                     <a:schemeClr val="accent1"/>
                   </a:solidFill>
@@ -8772,7 +8990,7 @@
             <a:p>
               <a:pPr algn="l"/>
               <a:r>
-                <a:rPr lang="en" sz="1500" dirty="0">
+                <a:rPr lang="en" sz="1500">
                   <a:solidFill>
                     <a:schemeClr val="accent5"/>
                   </a:solidFill>
@@ -8812,7 +9030,7 @@
             <a:p>
               <a:pPr algn="l"/>
               <a:r>
-                <a:rPr lang="en" sz="1050" dirty="0">
+                <a:rPr lang="en" sz="1050">
                   <a:solidFill>
                     <a:schemeClr val="accent5"/>
                   </a:solidFill>
@@ -8852,7 +9070,7 @@
             <a:p>
               <a:pPr algn="l"/>
               <a:r>
-                <a:rPr lang="en" sz="1050" dirty="0">
+                <a:rPr lang="en" sz="1050">
                   <a:solidFill>
                     <a:schemeClr val="accent2"/>
                   </a:solidFill>
@@ -8907,7 +9125,7 @@
             <a:p>
               <a:pPr algn="l"/>
               <a:r>
-                <a:rPr lang="en" sz="2400" dirty="0">
+                <a:rPr lang="en" sz="2400">
                   <a:solidFill>
                     <a:schemeClr val="accent1"/>
                   </a:solidFill>
@@ -8918,7 +9136,7 @@
                 <a:t>Different trade-offs. </a:t>
               </a:r>
               <a:r>
-                <a:rPr lang="en" sz="2400" b="1" dirty="0">
+                <a:rPr lang="en" sz="2400" b="1">
                   <a:solidFill>
                     <a:schemeClr val="accent2"/>
                   </a:solidFill>
@@ -8973,7 +9191,7 @@
             <a:p>
               <a:pPr algn="l"/>
               <a:r>
-                <a:rPr lang="en" sz="1050" dirty="0">
+                <a:rPr lang="en" sz="1050">
                   <a:solidFill>
                     <a:schemeClr val="accent5"/>
                   </a:solidFill>
@@ -9013,7 +9231,7 @@
             <a:p>
               <a:pPr algn="r"/>
               <a:r>
-                <a:rPr lang="en" sz="1050" dirty="0">
+                <a:rPr lang="en" sz="1050">
                   <a:solidFill>
                     <a:schemeClr val="accent5"/>
                   </a:solidFill>
@@ -9113,7 +9331,7 @@
             <a:p>
               <a:pPr algn="l"/>
               <a:r>
-                <a:rPr lang="en" sz="2400" b="1" dirty="0">
+                <a:rPr lang="en" sz="2400" b="1">
                   <a:solidFill>
                     <a:schemeClr val="accent2"/>
                   </a:solidFill>
@@ -9153,7 +9371,7 @@
             <a:p>
               <a:pPr algn="l"/>
               <a:r>
-                <a:rPr lang="en" sz="3600" b="1" dirty="0">
+                <a:rPr lang="en" sz="3600" b="1">
                   <a:solidFill>
                     <a:schemeClr val="accent1"/>
                   </a:solidFill>
@@ -9208,7 +9426,7 @@
             <a:p>
               <a:pPr algn="ctr"/>
               <a:r>
-                <a:rPr lang="en" sz="2100" dirty="0">
+                <a:rPr lang="en" sz="2100">
                   <a:solidFill>
                     <a:schemeClr val="accent1"/>
                   </a:solidFill>
@@ -9248,7 +9466,7 @@
             <a:p>
               <a:pPr algn="ctr"/>
               <a:r>
-                <a:rPr lang="en" sz="2100" dirty="0">
+                <a:rPr lang="en" sz="2100">
                   <a:solidFill>
                     <a:schemeClr val="accent1"/>
                   </a:solidFill>
@@ -9404,7 +9622,7 @@
             <a:p>
               <a:pPr algn="ctr"/>
               <a:r>
-                <a:rPr lang="en" sz="1500" dirty="0">
+                <a:rPr lang="en" sz="1500">
                   <a:solidFill>
                     <a:schemeClr val="accent5"/>
                   </a:solidFill>
@@ -9474,7 +9692,7 @@
             <a:p>
               <a:pPr algn="ctr"/>
               <a:r>
-                <a:rPr lang="en" sz="1500" dirty="0">
+                <a:rPr lang="en" sz="1500">
                   <a:solidFill>
                     <a:schemeClr val="accent5"/>
                   </a:solidFill>
@@ -9514,7 +9732,7 @@
             <a:p>
               <a:pPr algn="l"/>
               <a:r>
-                <a:rPr lang="en" sz="1500" dirty="0">
+                <a:rPr lang="en" sz="1500">
                   <a:solidFill>
                     <a:srgbClr val="B36A13"/>
                   </a:solidFill>
@@ -9584,7 +9802,7 @@
             <a:p>
               <a:pPr algn="ctr"/>
               <a:r>
-                <a:rPr lang="en" sz="1500" dirty="0">
+                <a:rPr lang="en" sz="1500">
                   <a:solidFill>
                     <a:schemeClr val="accent5"/>
                   </a:solidFill>
@@ -9654,7 +9872,7 @@
             <a:p>
               <a:pPr algn="ctr"/>
               <a:r>
-                <a:rPr lang="en" sz="1500" dirty="0">
+                <a:rPr lang="en" sz="1500">
                   <a:solidFill>
                     <a:schemeClr val="accent3"/>
                   </a:solidFill>
@@ -9694,7 +9912,7 @@
             <a:p>
               <a:pPr algn="l"/>
               <a:r>
-                <a:rPr lang="en" sz="1500" dirty="0">
+                <a:rPr lang="en" sz="1500">
                   <a:solidFill>
                     <a:schemeClr val="accent5"/>
                   </a:solidFill>
@@ -9734,7 +9952,7 @@
             <a:p>
               <a:pPr algn="l"/>
               <a:r>
-                <a:rPr lang="en" sz="1050" dirty="0">
+                <a:rPr lang="en" sz="1050">
                   <a:solidFill>
                     <a:schemeClr val="accent5"/>
                   </a:solidFill>
@@ -9822,7 +10040,7 @@
                 </a:lnSpc>
               </a:pPr>
               <a:r>
-                <a:rPr lang="en" sz="2400" b="1" dirty="0">
+                <a:rPr lang="en" sz="2400" b="1">
                   <a:solidFill>
                     <a:schemeClr val="accent1"/>
                   </a:solidFill>
@@ -9833,7 +10051,7 @@
                 <a:t>Ask at regular</a:t>
               </a:r>
               <a:br>
-                <a:rPr lang="en" sz="2400" b="1" dirty="0">
+                <a:rPr lang="en" sz="2400" b="1">
                   <a:solidFill>
                     <a:schemeClr val="accent1"/>
                   </a:solidFill>
@@ -9843,7 +10061,7 @@
                 </a:rPr>
               </a:br>
               <a:r>
-                <a:rPr lang="en" sz="2400" b="1" dirty="0">
+                <a:rPr lang="en" sz="2400" b="1">
                   <a:solidFill>
                     <a:schemeClr val="accent1"/>
                   </a:solidFill>
@@ -9883,7 +10101,7 @@
             <a:p>
               <a:pPr algn="l"/>
               <a:r>
-                <a:rPr lang="en" sz="2100" dirty="0">
+                <a:rPr lang="en" sz="2100">
                   <a:solidFill>
                     <a:schemeClr val="dk1"/>
                   </a:solidFill>
@@ -9923,7 +10141,7 @@
             <a:p>
               <a:pPr algn="l"/>
               <a:r>
-                <a:rPr lang="en" sz="2100" dirty="0">
+                <a:rPr lang="en" sz="2100">
                   <a:solidFill>
                     <a:schemeClr val="dk1"/>
                   </a:solidFill>
@@ -9963,7 +10181,7 @@
             <a:p>
               <a:pPr algn="l"/>
               <a:r>
-                <a:rPr lang="en" sz="1500" dirty="0">
+                <a:rPr lang="en" sz="1500">
                   <a:solidFill>
                     <a:srgbClr val="B36A13"/>
                   </a:solidFill>
@@ -10003,7 +10221,7 @@
             <a:p>
               <a:pPr algn="l"/>
               <a:r>
-                <a:rPr lang="en" sz="1500" dirty="0">
+                <a:rPr lang="en" sz="1500">
                   <a:solidFill>
                     <a:schemeClr val="accent5"/>
                   </a:solidFill>
@@ -10058,7 +10276,7 @@
             <a:p>
               <a:pPr algn="l"/>
               <a:r>
-                <a:rPr lang="en" sz="1050" dirty="0">
+                <a:rPr lang="en" sz="1050">
                   <a:solidFill>
                     <a:schemeClr val="accent5"/>
                   </a:solidFill>
@@ -10098,7 +10316,7 @@
             <a:p>
               <a:pPr algn="r"/>
               <a:r>
-                <a:rPr lang="en" sz="1050" dirty="0">
+                <a:rPr lang="en" sz="1050">
                   <a:solidFill>
                     <a:schemeClr val="accent5"/>
                   </a:solidFill>
@@ -10198,7 +10416,7 @@
             <a:p>
               <a:pPr algn="l"/>
               <a:r>
-                <a:rPr lang="en" sz="2400" b="1" dirty="0">
+                <a:rPr lang="en" sz="2400" b="1">
                   <a:solidFill>
                     <a:schemeClr val="accent2"/>
                   </a:solidFill>
@@ -10238,7 +10456,7 @@
             <a:p>
               <a:pPr algn="l"/>
               <a:r>
-                <a:rPr lang="en" sz="3600" b="1" dirty="0">
+                <a:rPr lang="en" sz="3600" b="1">
                   <a:solidFill>
                     <a:schemeClr val="accent1"/>
                   </a:solidFill>
@@ -10293,7 +10511,7 @@
             <a:p>
               <a:pPr algn="ctr"/>
               <a:r>
-                <a:rPr lang="en" sz="2100" dirty="0">
+                <a:rPr lang="en" sz="2100">
                   <a:solidFill>
                     <a:schemeClr val="accent1"/>
                   </a:solidFill>
@@ -10333,7 +10551,7 @@
             <a:p>
               <a:pPr algn="ctr"/>
               <a:r>
-                <a:rPr lang="en" sz="2100" dirty="0">
+                <a:rPr lang="en" sz="2100">
                   <a:solidFill>
                     <a:schemeClr val="accent1"/>
                   </a:solidFill>
@@ -10489,7 +10707,7 @@
             <a:p>
               <a:pPr algn="ctr"/>
               <a:r>
-                <a:rPr lang="en" sz="1500" dirty="0">
+                <a:rPr lang="en" sz="1500">
                   <a:solidFill>
                     <a:schemeClr val="accent5"/>
                   </a:solidFill>
@@ -10562,7 +10780,7 @@
             <a:p>
               <a:pPr algn="r"/>
               <a:r>
-                <a:rPr lang="en" sz="1500" dirty="0">
+                <a:rPr lang="en" sz="1500">
                   <a:solidFill>
                     <a:schemeClr val="accent2"/>
                   </a:solidFill>
@@ -10602,7 +10820,7 @@
             <a:p>
               <a:pPr algn="r"/>
               <a:r>
-                <a:rPr lang="en" sz="1500" dirty="0">
+                <a:rPr lang="en" sz="1500">
                   <a:solidFill>
                     <a:schemeClr val="accent5"/>
                   </a:solidFill>
@@ -10672,7 +10890,7 @@
             <a:p>
               <a:pPr algn="ctr"/>
               <a:r>
-                <a:rPr lang="en" sz="1500" dirty="0">
+                <a:rPr lang="en" sz="1500">
                   <a:solidFill>
                     <a:schemeClr val="accent3"/>
                   </a:solidFill>
@@ -10742,7 +10960,7 @@
             <a:p>
               <a:pPr algn="ctr"/>
               <a:r>
-                <a:rPr lang="en" sz="1500" dirty="0">
+                <a:rPr lang="en" sz="1500">
                   <a:solidFill>
                     <a:schemeClr val="accent5"/>
                   </a:solidFill>
@@ -10782,7 +11000,7 @@
             <a:p>
               <a:pPr algn="l"/>
               <a:r>
-                <a:rPr lang="en" sz="1050" dirty="0">
+                <a:rPr lang="en" sz="1050">
                   <a:solidFill>
                     <a:schemeClr val="accent5"/>
                   </a:solidFill>
@@ -10870,7 +11088,7 @@
                 </a:lnSpc>
               </a:pPr>
               <a:r>
-                <a:rPr lang="en" sz="2400" b="1" dirty="0">
+                <a:rPr lang="en" sz="2400" b="1">
                   <a:solidFill>
                     <a:schemeClr val="accent1"/>
                   </a:solidFill>
@@ -10881,7 +11099,7 @@
                 <a:t>Wait for an update.</a:t>
               </a:r>
               <a:br>
-                <a:rPr lang="en" sz="2400" b="1" dirty="0">
+                <a:rPr lang="en" sz="2400" b="1">
                   <a:solidFill>
                     <a:schemeClr val="accent1"/>
                   </a:solidFill>
@@ -10891,7 +11109,7 @@
                 </a:rPr>
               </a:br>
               <a:r>
-                <a:rPr lang="en" sz="2400" b="1" dirty="0">
+                <a:rPr lang="en" sz="2400" b="1">
                   <a:solidFill>
                     <a:schemeClr val="accent1"/>
                   </a:solidFill>
@@ -10931,7 +11149,7 @@
             <a:p>
               <a:pPr algn="l"/>
               <a:r>
-                <a:rPr lang="en" sz="2100" dirty="0">
+                <a:rPr lang="en" sz="2100">
                   <a:solidFill>
                     <a:schemeClr val="dk1"/>
                   </a:solidFill>
@@ -10971,7 +11189,7 @@
             <a:p>
               <a:pPr algn="l"/>
               <a:r>
-                <a:rPr lang="en" sz="2100" dirty="0">
+                <a:rPr lang="en" sz="2100">
                   <a:solidFill>
                     <a:schemeClr val="dk1"/>
                   </a:solidFill>
@@ -11011,7 +11229,7 @@
             <a:p>
               <a:pPr algn="l"/>
               <a:r>
-                <a:rPr lang="en" sz="1500" dirty="0">
+                <a:rPr lang="en" sz="1500">
                   <a:solidFill>
                     <a:srgbClr val="B36A13"/>
                   </a:solidFill>
@@ -11051,7 +11269,7 @@
             <a:p>
               <a:pPr algn="l"/>
               <a:r>
-                <a:rPr lang="en" sz="1500" dirty="0">
+                <a:rPr lang="en" sz="1500">
                   <a:solidFill>
                     <a:schemeClr val="accent5"/>
                   </a:solidFill>
@@ -11106,7 +11324,7 @@
             <a:p>
               <a:pPr algn="l"/>
               <a:r>
-                <a:rPr lang="en" sz="1050" dirty="0">
+                <a:rPr lang="en" sz="1050">
                   <a:solidFill>
                     <a:schemeClr val="accent5"/>
                   </a:solidFill>
@@ -11146,7 +11364,7 @@
             <a:p>
               <a:pPr algn="r"/>
               <a:r>
-                <a:rPr lang="en" sz="1050" dirty="0">
+                <a:rPr lang="en" sz="1050">
                   <a:solidFill>
                     <a:schemeClr val="accent5"/>
                   </a:solidFill>
@@ -11246,7 +11464,7 @@
             <a:p>
               <a:pPr algn="l"/>
               <a:r>
-                <a:rPr lang="en" sz="2400" b="1" dirty="0">
+                <a:rPr lang="en" sz="2400" b="1">
                   <a:solidFill>
                     <a:schemeClr val="accent2"/>
                   </a:solidFill>
@@ -11286,7 +11504,7 @@
             <a:p>
               <a:pPr algn="l"/>
               <a:r>
-                <a:rPr lang="en" sz="3600" b="1" dirty="0">
+                <a:rPr lang="en" sz="3600" b="1">
                   <a:solidFill>
                     <a:schemeClr val="accent1"/>
                   </a:solidFill>
@@ -11341,7 +11559,7 @@
             <a:p>
               <a:pPr algn="ctr"/>
               <a:r>
-                <a:rPr lang="en" sz="2100" dirty="0">
+                <a:rPr lang="en" sz="2100">
                   <a:solidFill>
                     <a:schemeClr val="accent1"/>
                   </a:solidFill>
@@ -11381,7 +11599,7 @@
             <a:p>
               <a:pPr algn="ctr"/>
               <a:r>
-                <a:rPr lang="en" sz="2100" dirty="0">
+                <a:rPr lang="en" sz="2100">
                   <a:solidFill>
                     <a:schemeClr val="accent1"/>
                   </a:solidFill>
@@ -11568,7 +11786,7 @@
             <a:p>
               <a:pPr algn="ctr"/>
               <a:r>
-                <a:rPr lang="en" sz="1500" dirty="0">
+                <a:rPr lang="en" sz="1500">
                   <a:solidFill>
                     <a:schemeClr val="accent5"/>
                   </a:solidFill>
@@ -11638,7 +11856,7 @@
             <a:p>
               <a:pPr algn="ctr"/>
               <a:r>
-                <a:rPr lang="en" sz="1500" dirty="0">
+                <a:rPr lang="en" sz="1500">
                   <a:solidFill>
                     <a:schemeClr val="accent2"/>
                   </a:solidFill>
@@ -11708,7 +11926,7 @@
             <a:p>
               <a:pPr algn="ctr"/>
               <a:r>
-                <a:rPr lang="en" sz="1500" dirty="0">
+                <a:rPr lang="en" sz="1500">
                   <a:solidFill>
                     <a:schemeClr val="accent2"/>
                   </a:solidFill>
@@ -11778,7 +11996,7 @@
             <a:p>
               <a:pPr algn="ctr"/>
               <a:r>
-                <a:rPr lang="en" sz="1500" dirty="0">
+                <a:rPr lang="en" sz="1500">
                   <a:solidFill>
                     <a:schemeClr val="accent2"/>
                   </a:solidFill>
@@ -11818,7 +12036,7 @@
             <a:p>
               <a:pPr algn="ctr"/>
               <a:r>
-                <a:rPr lang="en" sz="1500" dirty="0">
+                <a:rPr lang="en" sz="1500">
                   <a:solidFill>
                     <a:schemeClr val="accent5"/>
                   </a:solidFill>
@@ -11858,7 +12076,7 @@
             <a:p>
               <a:pPr algn="l"/>
               <a:r>
-                <a:rPr lang="en" sz="1050" dirty="0">
+                <a:rPr lang="en" sz="1050">
                   <a:solidFill>
                     <a:schemeClr val="accent5"/>
                   </a:solidFill>
@@ -11946,7 +12164,7 @@
                 </a:lnSpc>
               </a:pPr>
               <a:r>
-                <a:rPr lang="en" sz="2400" b="1" dirty="0">
+                <a:rPr lang="en" sz="2400" b="1">
                   <a:solidFill>
                     <a:schemeClr val="accent1"/>
                   </a:solidFill>
@@ -11957,7 +12175,7 @@
                 <a:t>One open stream.</a:t>
               </a:r>
               <a:br>
-                <a:rPr lang="en" sz="2400" b="1" dirty="0">
+                <a:rPr lang="en" sz="2400" b="1">
                   <a:solidFill>
                     <a:schemeClr val="accent1"/>
                   </a:solidFill>
@@ -11967,7 +12185,7 @@
                 </a:rPr>
               </a:br>
               <a:r>
-                <a:rPr lang="en" sz="2400" b="1" dirty="0">
+                <a:rPr lang="en" sz="2400" b="1">
                   <a:solidFill>
                     <a:schemeClr val="accent1"/>
                   </a:solidFill>
@@ -12157,7 +12375,7 @@
             <a:p>
               <a:pPr algn="l"/>
               <a:r>
-                <a:rPr lang="en" sz="1500" dirty="0">
+                <a:rPr lang="en" sz="1500">
                   <a:solidFill>
                     <a:schemeClr val="accent2"/>
                   </a:solidFill>
@@ -12197,7 +12415,7 @@
             <a:p>
               <a:pPr algn="l"/>
               <a:r>
-                <a:rPr lang="en" sz="2100" dirty="0">
+                <a:rPr lang="en" sz="2100">
                   <a:solidFill>
                     <a:schemeClr val="dk1"/>
                   </a:solidFill>
@@ -12237,7 +12455,7 @@
             <a:p>
               <a:pPr algn="l"/>
               <a:r>
-                <a:rPr lang="en" sz="1500" dirty="0">
+                <a:rPr lang="en" sz="1500">
                   <a:solidFill>
                     <a:schemeClr val="accent5"/>
                   </a:solidFill>
@@ -12277,7 +12495,7 @@
             <a:p>
               <a:pPr algn="l"/>
               <a:r>
-                <a:rPr lang="en" sz="1500" dirty="0">
+                <a:rPr lang="en" sz="1500">
                   <a:solidFill>
                     <a:srgbClr val="B36A13"/>
                   </a:solidFill>
@@ -12317,7 +12535,7 @@
             <a:p>
               <a:pPr algn="l"/>
               <a:r>
-                <a:rPr lang="en" sz="1500" dirty="0">
+                <a:rPr lang="en" sz="1500">
                   <a:solidFill>
                     <a:schemeClr val="accent5"/>
                   </a:solidFill>
@@ -12372,7 +12590,7 @@
             <a:p>
               <a:pPr algn="l"/>
               <a:r>
-                <a:rPr lang="en" sz="1050" dirty="0">
+                <a:rPr lang="en" sz="1050">
                   <a:solidFill>
                     <a:schemeClr val="accent5"/>
                   </a:solidFill>
@@ -12412,7 +12630,7 @@
             <a:p>
               <a:pPr algn="r"/>
               <a:r>
-                <a:rPr lang="en" sz="1050" dirty="0">
+                <a:rPr lang="en" sz="1050">
                   <a:solidFill>
                     <a:schemeClr val="accent5"/>
                   </a:solidFill>
@@ -12512,7 +12730,7 @@
             <a:p>
               <a:pPr algn="l"/>
               <a:r>
-                <a:rPr lang="en" sz="2400" b="1" dirty="0">
+                <a:rPr lang="en" sz="2400" b="1">
                   <a:solidFill>
                     <a:schemeClr val="accent2"/>
                   </a:solidFill>
@@ -12552,7 +12770,7 @@
             <a:p>
               <a:pPr algn="l"/>
               <a:r>
-                <a:rPr lang="en" sz="3600" b="1" dirty="0">
+                <a:rPr lang="en" sz="3600" b="1">
                   <a:solidFill>
                     <a:schemeClr val="accent1"/>
                   </a:solidFill>
@@ -12607,7 +12825,7 @@
             <a:p>
               <a:pPr algn="ctr"/>
               <a:r>
-                <a:rPr lang="en" sz="2100" dirty="0">
+                <a:rPr lang="en" sz="2100">
                   <a:solidFill>
                     <a:schemeClr val="accent1"/>
                   </a:solidFill>
@@ -12647,7 +12865,7 @@
             <a:p>
               <a:pPr algn="ctr"/>
               <a:r>
-                <a:rPr lang="en" sz="2100" dirty="0">
+                <a:rPr lang="en" sz="2100">
                   <a:solidFill>
                     <a:schemeClr val="accent1"/>
                   </a:solidFill>
@@ -12834,7 +13052,7 @@
             <a:p>
               <a:pPr algn="ctr"/>
               <a:r>
-                <a:rPr lang="en" sz="1500" dirty="0">
+                <a:rPr lang="en" sz="1500">
                   <a:solidFill>
                     <a:schemeClr val="accent5"/>
                   </a:solidFill>
@@ -12904,7 +13122,7 @@
             <a:p>
               <a:pPr algn="ctr"/>
               <a:r>
-                <a:rPr lang="en" sz="1500" dirty="0">
+                <a:rPr lang="en" sz="1500">
                   <a:solidFill>
                     <a:schemeClr val="accent5"/>
                   </a:solidFill>
@@ -12974,7 +13192,7 @@
             <a:p>
               <a:pPr algn="ctr"/>
               <a:r>
-                <a:rPr lang="en" sz="1500" dirty="0">
+                <a:rPr lang="en" sz="1500">
                   <a:solidFill>
                     <a:schemeClr val="accent2"/>
                   </a:solidFill>
@@ -13044,7 +13262,7 @@
             <a:p>
               <a:pPr algn="ctr"/>
               <a:r>
-                <a:rPr lang="en" sz="1500" dirty="0">
+                <a:rPr lang="en" sz="1500">
                   <a:solidFill>
                     <a:schemeClr val="accent2"/>
                   </a:solidFill>
@@ -13114,7 +13332,7 @@
             <a:p>
               <a:pPr algn="ctr"/>
               <a:r>
-                <a:rPr lang="en" sz="1500" dirty="0">
+                <a:rPr lang="en" sz="1500">
                   <a:solidFill>
                     <a:schemeClr val="accent2"/>
                   </a:solidFill>
@@ -13154,7 +13372,7 @@
             <a:p>
               <a:pPr algn="ctr"/>
               <a:r>
-                <a:rPr lang="en" sz="1500" dirty="0">
+                <a:rPr lang="en" sz="1500">
                   <a:solidFill>
                     <a:schemeClr val="accent5"/>
                   </a:solidFill>
@@ -13194,7 +13412,7 @@
             <a:p>
               <a:pPr algn="l"/>
               <a:r>
-                <a:rPr lang="en" sz="1050" dirty="0">
+                <a:rPr lang="en" sz="1050">
                   <a:solidFill>
                     <a:schemeClr val="accent5"/>
                   </a:solidFill>
@@ -13282,7 +13500,7 @@
                 </a:lnSpc>
               </a:pPr>
               <a:r>
-                <a:rPr lang="en" sz="2400" b="1" dirty="0">
+                <a:rPr lang="en" sz="2400" b="1">
                   <a:solidFill>
                     <a:schemeClr val="accent1"/>
                   </a:solidFill>
@@ -13293,7 +13511,7 @@
                 <a:t>One connection.</a:t>
               </a:r>
               <a:br>
-                <a:rPr lang="en" sz="2400" b="1" dirty="0">
+                <a:rPr lang="en" sz="2400" b="1">
                   <a:solidFill>
                     <a:schemeClr val="accent1"/>
                   </a:solidFill>
@@ -13303,7 +13521,7 @@
                 </a:rPr>
               </a:br>
               <a:r>
-                <a:rPr lang="en" sz="2400" b="1" dirty="0">
+                <a:rPr lang="en" sz="2400" b="1">
                   <a:solidFill>
                     <a:schemeClr val="accent1"/>
                   </a:solidFill>
@@ -13409,7 +13627,7 @@
             <a:p>
               <a:pPr algn="l"/>
               <a:r>
-                <a:rPr lang="en" sz="1500" dirty="0">
+                <a:rPr lang="en" sz="1500">
                   <a:solidFill>
                     <a:schemeClr val="accent2"/>
                   </a:solidFill>
@@ -13449,7 +13667,7 @@
             <a:p>
               <a:pPr algn="l"/>
               <a:r>
-                <a:rPr lang="en" sz="2100" dirty="0">
+                <a:rPr lang="en" sz="2100">
                   <a:solidFill>
                     <a:schemeClr val="dk1"/>
                   </a:solidFill>
@@ -13489,7 +13707,7 @@
             <a:p>
               <a:pPr algn="l"/>
               <a:r>
-                <a:rPr lang="en" sz="1500" dirty="0">
+                <a:rPr lang="en" sz="1500">
                   <a:solidFill>
                     <a:schemeClr val="accent5"/>
                   </a:solidFill>
@@ -13529,7 +13747,7 @@
             <a:p>
               <a:pPr algn="l"/>
               <a:r>
-                <a:rPr lang="en" sz="1500" dirty="0">
+                <a:rPr lang="en" sz="1500">
                   <a:solidFill>
                     <a:srgbClr val="B36A13"/>
                   </a:solidFill>
@@ -13569,7 +13787,7 @@
             <a:p>
               <a:pPr algn="l"/>
               <a:r>
-                <a:rPr lang="en" sz="1500" dirty="0">
+                <a:rPr lang="en" sz="1500">
                   <a:solidFill>
                     <a:schemeClr val="accent5"/>
                   </a:solidFill>
@@ -13624,7 +13842,7 @@
             <a:p>
               <a:pPr algn="l"/>
               <a:r>
-                <a:rPr lang="en" sz="1050" dirty="0">
+                <a:rPr lang="en" sz="1050">
                   <a:solidFill>
                     <a:schemeClr val="accent5"/>
                   </a:solidFill>
@@ -13664,7 +13882,7 @@
             <a:p>
               <a:pPr algn="r"/>
               <a:r>
-                <a:rPr lang="en" sz="1050" dirty="0">
+                <a:rPr lang="en" sz="1050">
                   <a:solidFill>
                     <a:schemeClr val="accent5"/>
                   </a:solidFill>

</xml_diff>